<commit_message>
docs: add case-study appendix to presentation deck
Nine new slides (one divider + eight case-study slides) walking the
30m 13s /run that built webhooksig — invocation, interrogation, spec,
security concerns, architecture, parallel coders + advisor, karen
triage, final scoreboard, and the JSONL audit trail.

build_deck.py gains prep_image() and find_screenshot() helpers that
downscale source PNGs from pptx_refs/ into docs/assets/case-study/ as
quality-85 JPEGs. Source filenames contain U+202F (narrow no-break
space) before AM, so lookup uses glob rather than literal path.

add_picture_fit() preserves aspect ratio and centers each shot inside
its bounding box. Final deck weighs ~1.4 MB.
</commit_message>
<xml_diff>
--- a/docs/EFF-IT.pptx
+++ b/docs/EFF-IT.pptx
@@ -19,6 +19,15 @@
     <p:sldId id="267" r:id="rId19"/>
     <p:sldId id="268" r:id="rId20"/>
     <p:sldId id="269" r:id="rId21"/>
+    <p:sldId id="270" r:id="rId22"/>
+    <p:sldId id="271" r:id="rId23"/>
+    <p:sldId id="272" r:id="rId24"/>
+    <p:sldId id="273" r:id="rId25"/>
+    <p:sldId id="274" r:id="rId26"/>
+    <p:sldId id="275" r:id="rId27"/>
+    <p:sldId id="276" r:id="rId28"/>
+    <p:sldId id="277" r:id="rId29"/>
+    <p:sldId id="278" r:id="rId30"/>
   </p:sldIdLst>
   <p:sldSz cx="12191695" cy="6858000" type="screen4x3"/>
   <p:notesSz cx="6858000" cy="9144000"/>
@@ -1097,6 +1106,438 @@
 </p:notes>
 </file>
 
+<file path=ppt/notesSlides/notesSlide15.xml><?xml version="1.0" encoding="utf-8"?>
+<p:notes xmlns:a="http://schemas.openxmlformats.org/drawingml/2006/main" xmlns:p="http://schemas.openxmlformats.org/presentationml/2006/main" xmlns:r="http://schemas.openxmlformats.org/officeDocument/2006/relationships">
+  <p:cSld>
+    <p:spTree>
+      <p:nvGrpSpPr>
+        <p:cNvPr id="1" name=""/>
+        <p:cNvGrpSpPr/>
+        <p:nvPr/>
+      </p:nvGrpSpPr>
+      <p:grpSpPr>
+        <a:xfrm>
+          <a:off x="0" y="0"/>
+          <a:ext cx="0" cy="0"/>
+          <a:chOff x="0" y="0"/>
+          <a:chExt cx="0" cy="0"/>
+        </a:xfrm>
+      </p:grpSpPr>
+      <p:sp>
+        <p:nvSpPr>
+          <p:cNvPr id="2" name="Slide Image Placeholder 1"/>
+          <p:cNvSpPr>
+            <a:spLocks noGrp="1"/>
+          </p:cNvSpPr>
+          <p:nvPr>
+            <p:ph type="sldImg" idx="2"/>
+          </p:nvPr>
+        </p:nvSpPr>
+        <p:spPr/>
+      </p:sp>
+      <p:sp>
+        <p:nvSpPr>
+          <p:cNvPr id="3" name="Notes Placeholder 2"/>
+          <p:cNvSpPr>
+            <a:spLocks noGrp="1"/>
+          </p:cNvSpPr>
+          <p:nvPr>
+            <p:ph type="body" idx="3" sz="quarter"/>
+          </p:nvPr>
+        </p:nvSpPr>
+        <p:spPr/>
+        <p:txBody>
+          <a:bodyPr/>
+          <a:lstStyle/>
+          <a:p>
+            <a:r>
+              <a:t>Pause here. This is the pivot from 'here's the harness' to 'here's a real run of the harness, soup to nuts.'</a:t>
+            </a:r>
+          </a:p>
+          <a:p/>
+          <a:p>
+            <a:r>
+              <a:t>What to say:</a:t>
+            </a:r>
+          </a:p>
+          <a:p>
+            <a:r>
+              <a:t>'The rest of the talk was about the harness. The rest of the deck is what one run looks like in practice. Thirty minutes, twelve agents, one merged PR, five cents in tokens. We're going to walk every stage with the actual screenshots from that session.'</a:t>
+            </a:r>
+          </a:p>
+          <a:p/>
+          <a:p>
+            <a:r>
+              <a:t>If you have time and the audience is engaged, mention you can also play the full screen recording — it's in pptx_refs/ next to the deck. Don't try to embed a 30 MB .mov in the slides; just have it ready in a side window if asked.</a:t>
+            </a:r>
+          </a:p>
+        </p:txBody>
+      </p:sp>
+      <p:sp>
+        <p:nvSpPr>
+          <p:cNvPr id="4" name="Slide Number Placeholder 3"/>
+          <p:cNvSpPr>
+            <a:spLocks noGrp="1"/>
+          </p:cNvSpPr>
+          <p:nvPr>
+            <p:ph type="sldNum" idx="5" sz="quarter"/>
+          </p:nvPr>
+        </p:nvSpPr>
+        <p:spPr/>
+      </p:sp>
+    </p:spTree>
+  </p:cSld>
+  <p:clrMapOvr>
+    <a:masterClrMapping/>
+  </p:clrMapOvr>
+</p:notes>
+</file>
+
+<file path=ppt/notesSlides/notesSlide16.xml><?xml version="1.0" encoding="utf-8"?>
+<p:notes xmlns:a="http://schemas.openxmlformats.org/drawingml/2006/main" xmlns:p="http://schemas.openxmlformats.org/presentationml/2006/main" xmlns:r="http://schemas.openxmlformats.org/officeDocument/2006/relationships">
+  <p:cSld>
+    <p:spTree>
+      <p:nvGrpSpPr>
+        <p:cNvPr id="1" name=""/>
+        <p:cNvGrpSpPr/>
+        <p:nvPr/>
+      </p:nvGrpSpPr>
+      <p:grpSpPr>
+        <a:xfrm>
+          <a:off x="0" y="0"/>
+          <a:ext cx="0" cy="0"/>
+          <a:chOff x="0" y="0"/>
+          <a:chExt cx="0" cy="0"/>
+        </a:xfrm>
+      </p:grpSpPr>
+      <p:sp>
+        <p:nvSpPr>
+          <p:cNvPr id="2" name="Slide Image Placeholder 1"/>
+          <p:cNvSpPr>
+            <a:spLocks noGrp="1"/>
+          </p:cNvSpPr>
+          <p:nvPr>
+            <p:ph type="sldImg" idx="2"/>
+          </p:nvPr>
+        </p:nvSpPr>
+        <p:spPr/>
+      </p:sp>
+      <p:sp>
+        <p:nvSpPr>
+          <p:cNvPr id="3" name="Notes Placeholder 2"/>
+          <p:cNvSpPr>
+            <a:spLocks noGrp="1"/>
+          </p:cNvSpPr>
+          <p:nvPr>
+            <p:ph type="body" idx="3" sz="quarter"/>
+          </p:nvPr>
+        </p:nvSpPr>
+        <p:spPr/>
+        <p:txBody>
+          <a:bodyPr/>
+          <a:lstStyle/>
+          <a:p>
+            <a:r>
+              <a:t>Two screenshots, two beats:</a:t>
+            </a:r>
+          </a:p>
+          <a:p/>
+          <a:p>
+            <a:r>
+              <a:t>LEFT (10:41:53): 'This is what kicking off a run looks like — type /run, Claude Code prompts you to allow the skill. That's the only friction in the whole 30 minutes.'</a:t>
+            </a:r>
+          </a:p>
+          <a:p/>
+          <a:p>
+            <a:r>
+              <a:t>RIGHT (10:43:26): 'A minute and a half later, the interrogator has summarized the idea back to me. Note the prompt at the bottom — Is this the right one-liner, or do you want to refine it? It will not draft a spec until you confirm or correct.'</a:t>
+            </a:r>
+          </a:p>
+          <a:p/>
+          <a:p>
+            <a:r>
+              <a:t>Optional aside: the model badge in the bottom-left switched from Sonnet 4.6 to Opus 4.7 between these two screenshots. The skill actually suggested the swap because Opus does deeper interrogation. Small UX detail, but it tells you the harness is opinionated about model choice per stage.</a:t>
+            </a:r>
+          </a:p>
+        </p:txBody>
+      </p:sp>
+      <p:sp>
+        <p:nvSpPr>
+          <p:cNvPr id="4" name="Slide Number Placeholder 3"/>
+          <p:cNvSpPr>
+            <a:spLocks noGrp="1"/>
+          </p:cNvSpPr>
+          <p:nvPr>
+            <p:ph type="sldNum" idx="5" sz="quarter"/>
+          </p:nvPr>
+        </p:nvSpPr>
+        <p:spPr/>
+      </p:sp>
+    </p:spTree>
+  </p:cSld>
+  <p:clrMapOvr>
+    <a:masterClrMapping/>
+  </p:clrMapOvr>
+</p:notes>
+</file>
+
+<file path=ppt/notesSlides/notesSlide17.xml><?xml version="1.0" encoding="utf-8"?>
+<p:notes xmlns:a="http://schemas.openxmlformats.org/drawingml/2006/main" xmlns:p="http://schemas.openxmlformats.org/presentationml/2006/main" xmlns:r="http://schemas.openxmlformats.org/officeDocument/2006/relationships">
+  <p:cSld>
+    <p:spTree>
+      <p:nvGrpSpPr>
+        <p:cNvPr id="1" name=""/>
+        <p:cNvGrpSpPr/>
+        <p:nvPr/>
+      </p:nvGrpSpPr>
+      <p:grpSpPr>
+        <a:xfrm>
+          <a:off x="0" y="0"/>
+          <a:ext cx="0" cy="0"/>
+          <a:chOff x="0" y="0"/>
+          <a:chExt cx="0" cy="0"/>
+        </a:xfrm>
+      </p:grpSpPr>
+      <p:sp>
+        <p:nvSpPr>
+          <p:cNvPr id="2" name="Slide Image Placeholder 1"/>
+          <p:cNvSpPr>
+            <a:spLocks noGrp="1"/>
+          </p:cNvSpPr>
+          <p:nvPr>
+            <p:ph type="sldImg" idx="2"/>
+          </p:nvPr>
+        </p:nvSpPr>
+        <p:spPr/>
+      </p:sp>
+      <p:sp>
+        <p:nvSpPr>
+          <p:cNvPr id="3" name="Notes Placeholder 2"/>
+          <p:cNvSpPr>
+            <a:spLocks noGrp="1"/>
+          </p:cNvSpPr>
+          <p:nvPr>
+            <p:ph type="body" idx="3" sz="quarter"/>
+          </p:nvPr>
+        </p:nvSpPr>
+        <p:spPr/>
+        <p:txBody>
+          <a:bodyPr/>
+          <a:lstStyle/>
+          <a:p>
+            <a:r>
+              <a:t>Don't read the spec aloud. Let people scan it for ten seconds.</a:t>
+            </a:r>
+          </a:p>
+          <a:p/>
+          <a:p>
+            <a:r>
+              <a:t>What to say:</a:t>
+            </a:r>
+          </a:p>
+          <a:p>
+            <a:r>
+              <a:t>'Every section you see here came out of the interrogator's Q&amp;A. Goals, non-goals, intended users, scope boundaries. This file becomes the contract — karen, the auditor agent at the end of the pipeline, literally diffs the implementation against this spec to decide PASS, PARTIAL, or FAIL.'</a:t>
+            </a:r>
+          </a:p>
+          <a:p/>
+          <a:p>
+            <a:r>
+              <a:t>Land this point: 'In raw vibe coding, the spec lives in chat history and gets lost. Here, it's a file. You can read it, share it, and the agents can re-read it whenever they drift.'</a:t>
+            </a:r>
+          </a:p>
+        </p:txBody>
+      </p:sp>
+      <p:sp>
+        <p:nvSpPr>
+          <p:cNvPr id="4" name="Slide Number Placeholder 3"/>
+          <p:cNvSpPr>
+            <a:spLocks noGrp="1"/>
+          </p:cNvSpPr>
+          <p:nvPr>
+            <p:ph type="sldNum" idx="5" sz="quarter"/>
+          </p:nvPr>
+        </p:nvSpPr>
+        <p:spPr/>
+      </p:sp>
+    </p:spTree>
+  </p:cSld>
+  <p:clrMapOvr>
+    <a:masterClrMapping/>
+  </p:clrMapOvr>
+</p:notes>
+</file>
+
+<file path=ppt/notesSlides/notesSlide18.xml><?xml version="1.0" encoding="utf-8"?>
+<p:notes xmlns:a="http://schemas.openxmlformats.org/drawingml/2006/main" xmlns:p="http://schemas.openxmlformats.org/presentationml/2006/main" xmlns:r="http://schemas.openxmlformats.org/officeDocument/2006/relationships">
+  <p:cSld>
+    <p:spTree>
+      <p:nvGrpSpPr>
+        <p:cNvPr id="1" name=""/>
+        <p:cNvGrpSpPr/>
+        <p:nvPr/>
+      </p:nvGrpSpPr>
+      <p:grpSpPr>
+        <a:xfrm>
+          <a:off x="0" y="0"/>
+          <a:ext cx="0" cy="0"/>
+          <a:chOff x="0" y="0"/>
+          <a:chExt cx="0" cy="0"/>
+        </a:xfrm>
+      </p:grpSpPr>
+      <p:sp>
+        <p:nvSpPr>
+          <p:cNvPr id="2" name="Slide Image Placeholder 1"/>
+          <p:cNvSpPr>
+            <a:spLocks noGrp="1"/>
+          </p:cNvSpPr>
+          <p:nvPr>
+            <p:ph type="sldImg" idx="2"/>
+          </p:nvPr>
+        </p:nvSpPr>
+        <p:spPr/>
+      </p:sp>
+      <p:sp>
+        <p:nvSpPr>
+          <p:cNvPr id="3" name="Notes Placeholder 2"/>
+          <p:cNvSpPr>
+            <a:spLocks noGrp="1"/>
+          </p:cNvSpPr>
+          <p:nvPr>
+            <p:ph type="body" idx="3" sz="quarter"/>
+          </p:nvPr>
+        </p:nvSpPr>
+        <p:spPr/>
+        <p:txBody>
+          <a:bodyPr/>
+          <a:lstStyle/>
+          <a:p>
+            <a:r>
+              <a:t>These two screenshots are SECURITY_CONCERNS.md, top half on the left, bottom half on the right. Walk through what's on screen:</a:t>
+            </a:r>
+          </a:p>
+          <a:p/>
+          <a:p>
+            <a:r>
+              <a:t>'The concern-resolver looked at the SPEC, looked at app_types declared in CLAUDE.md, and produced this merged checklist. SR-1 is timing-safe comparison. SR-2 is replay protection. SR-3 is no-secret-in-logs. Every one of these has a triggered-by reason and a remediation hint.'</a:t>
+            </a:r>
+          </a:p>
+          <a:p/>
+          <a:p>
+            <a:r>
+              <a:t>The key point: this happens BEFORE implementation. The architect agent reads this file and bakes the mitigations into the design. The security-reviewer at the end reads the SAME file to verify nothing was missed. One checklist, three agents.</a:t>
+            </a:r>
+          </a:p>
+        </p:txBody>
+      </p:sp>
+      <p:sp>
+        <p:nvSpPr>
+          <p:cNvPr id="4" name="Slide Number Placeholder 3"/>
+          <p:cNvSpPr>
+            <a:spLocks noGrp="1"/>
+          </p:cNvSpPr>
+          <p:nvPr>
+            <p:ph type="sldNum" idx="5" sz="quarter"/>
+          </p:nvPr>
+        </p:nvSpPr>
+        <p:spPr/>
+      </p:sp>
+    </p:spTree>
+  </p:cSld>
+  <p:clrMapOvr>
+    <a:masterClrMapping/>
+  </p:clrMapOvr>
+</p:notes>
+</file>
+
+<file path=ppt/notesSlides/notesSlide19.xml><?xml version="1.0" encoding="utf-8"?>
+<p:notes xmlns:a="http://schemas.openxmlformats.org/drawingml/2006/main" xmlns:p="http://schemas.openxmlformats.org/presentationml/2006/main" xmlns:r="http://schemas.openxmlformats.org/officeDocument/2006/relationships">
+  <p:cSld>
+    <p:spTree>
+      <p:nvGrpSpPr>
+        <p:cNvPr id="1" name=""/>
+        <p:cNvGrpSpPr/>
+        <p:nvPr/>
+      </p:nvGrpSpPr>
+      <p:grpSpPr>
+        <a:xfrm>
+          <a:off x="0" y="0"/>
+          <a:ext cx="0" cy="0"/>
+          <a:chOff x="0" y="0"/>
+          <a:chExt cx="0" cy="0"/>
+        </a:xfrm>
+      </p:grpSpPr>
+      <p:sp>
+        <p:nvSpPr>
+          <p:cNvPr id="2" name="Slide Image Placeholder 1"/>
+          <p:cNvSpPr>
+            <a:spLocks noGrp="1"/>
+          </p:cNvSpPr>
+          <p:nvPr>
+            <p:ph type="sldImg" idx="2"/>
+          </p:nvPr>
+        </p:nvSpPr>
+        <p:spPr/>
+      </p:sp>
+      <p:sp>
+        <p:nvSpPr>
+          <p:cNvPr id="3" name="Notes Placeholder 2"/>
+          <p:cNvSpPr>
+            <a:spLocks noGrp="1"/>
+          </p:cNvSpPr>
+          <p:nvPr>
+            <p:ph type="body" idx="3" sz="quarter"/>
+          </p:nvPr>
+        </p:nvSpPr>
+        <p:spPr/>
+        <p:txBody>
+          <a:bodyPr/>
+          <a:lstStyle/>
+          <a:p>
+            <a:r>
+              <a:t>Two halves of one architecture doc.</a:t>
+            </a:r>
+          </a:p>
+          <a:p/>
+          <a:p>
+            <a:r>
+              <a:t>LEFT: system context diagram. Note the trust boundary — webhooksig sits INSIDE the caller's request handler, after TLS termination, before business logic. The architect agent drew this. ASCII art, not Mermaid — because it has to render in any markdown viewer, including git diff.</a:t>
+            </a:r>
+          </a:p>
+          <a:p/>
+          <a:p>
+            <a:r>
+              <a:t>RIGHT: the data-flow section. Pseudocode for the call path through verify_github and verify_stripe. This is the algorithm being settled BEFORE any code is written. By the time the coder agent gets a task, all of these decisions are pre-made.</a:t>
+            </a:r>
+          </a:p>
+          <a:p/>
+          <a:p>
+            <a:r>
+              <a:t>Land it: 'Most agent runs go straight from spec to code. The architect step is what stops the coder from re-deciding architecture in every function it writes.'</a:t>
+            </a:r>
+          </a:p>
+        </p:txBody>
+      </p:sp>
+      <p:sp>
+        <p:nvSpPr>
+          <p:cNvPr id="4" name="Slide Number Placeholder 3"/>
+          <p:cNvSpPr>
+            <a:spLocks noGrp="1"/>
+          </p:cNvSpPr>
+          <p:nvPr>
+            <p:ph type="sldNum" idx="5" sz="quarter"/>
+          </p:nvPr>
+        </p:nvSpPr>
+        <p:spPr/>
+      </p:sp>
+    </p:spTree>
+  </p:cSld>
+  <p:clrMapOvr>
+    <a:masterClrMapping/>
+  </p:clrMapOvr>
+</p:notes>
+</file>
+
 <file path=ppt/notesSlides/notesSlide2.xml><?xml version="1.0" encoding="utf-8"?>
 <p:notes xmlns:a="http://schemas.openxmlformats.org/drawingml/2006/main" xmlns:p="http://schemas.openxmlformats.org/presentationml/2006/main" xmlns:r="http://schemas.openxmlformats.org/officeDocument/2006/relationships">
   <p:cSld>
@@ -1181,6 +1622,416 @@
           <a:p>
             <a:r>
               <a:t>Transition: 'So I built something to fix that.'</a:t>
+            </a:r>
+          </a:p>
+        </p:txBody>
+      </p:sp>
+      <p:sp>
+        <p:nvSpPr>
+          <p:cNvPr id="4" name="Slide Number Placeholder 3"/>
+          <p:cNvSpPr>
+            <a:spLocks noGrp="1"/>
+          </p:cNvSpPr>
+          <p:nvPr>
+            <p:ph type="sldNum" idx="5" sz="quarter"/>
+          </p:nvPr>
+        </p:nvSpPr>
+        <p:spPr/>
+      </p:sp>
+    </p:spTree>
+  </p:cSld>
+  <p:clrMapOvr>
+    <a:masterClrMapping/>
+  </p:clrMapOvr>
+</p:notes>
+</file>
+
+<file path=ppt/notesSlides/notesSlide20.xml><?xml version="1.0" encoding="utf-8"?>
+<p:notes xmlns:a="http://schemas.openxmlformats.org/drawingml/2006/main" xmlns:p="http://schemas.openxmlformats.org/presentationml/2006/main" xmlns:r="http://schemas.openxmlformats.org/officeDocument/2006/relationships">
+  <p:cSld>
+    <p:spTree>
+      <p:nvGrpSpPr>
+        <p:cNvPr id="1" name=""/>
+        <p:cNvGrpSpPr/>
+        <p:nvPr/>
+      </p:nvGrpSpPr>
+      <p:grpSpPr>
+        <a:xfrm>
+          <a:off x="0" y="0"/>
+          <a:ext cx="0" cy="0"/>
+          <a:chOff x="0" y="0"/>
+          <a:chExt cx="0" cy="0"/>
+        </a:xfrm>
+      </p:grpSpPr>
+      <p:sp>
+        <p:nvSpPr>
+          <p:cNvPr id="2" name="Slide Image Placeholder 1"/>
+          <p:cNvSpPr>
+            <a:spLocks noGrp="1"/>
+          </p:cNvSpPr>
+          <p:nvPr>
+            <p:ph type="sldImg" idx="2"/>
+          </p:nvPr>
+        </p:nvSpPr>
+        <p:spPr/>
+      </p:sp>
+      <p:sp>
+        <p:nvSpPr>
+          <p:cNvPr id="3" name="Notes Placeholder 2"/>
+          <p:cNvSpPr>
+            <a:spLocks noGrp="1"/>
+          </p:cNvSpPr>
+          <p:nvPr>
+            <p:ph type="body" idx="3" sz="quarter"/>
+          </p:nvPr>
+        </p:nvSpPr>
+        <p:spPr/>
+        <p:txBody>
+          <a:bodyPr/>
+          <a:lstStyle/>
+          <a:p>
+            <a:r>
+              <a:t>LEFT: 'Four agents running in parallel — fixing test mismatches and implementing the P2 module tier.' This is the orchestrator's decomposition paying off — independent tasks fan out to independent coders. Wall-clock for this phase: under five minutes.</a:t>
+            </a:r>
+          </a:p>
+          <a:p/>
+          <a:p>
+            <a:r>
+              <a:t>RIGHT: this is the moment that justifies the advisor tool. The coder hit an ambiguous spec edge — what's the right max_header_length bound? Instead of guessing, it consulted the stronger advisor model. The advisor reviewed the full transcript and confirmed the approach.</a:t>
+            </a:r>
+          </a:p>
+          <a:p/>
+          <a:p>
+            <a:r>
+              <a:t>Key point: 'The advisor isn't a fallback for failure. It's a second-opinion mechanism for decisions that have consequences. The coder used it correctly here — at a branch point, before committing to an interpretation.'</a:t>
+            </a:r>
+          </a:p>
+        </p:txBody>
+      </p:sp>
+      <p:sp>
+        <p:nvSpPr>
+          <p:cNvPr id="4" name="Slide Number Placeholder 3"/>
+          <p:cNvSpPr>
+            <a:spLocks noGrp="1"/>
+          </p:cNvSpPr>
+          <p:nvPr>
+            <p:ph type="sldNum" idx="5" sz="quarter"/>
+          </p:nvPr>
+        </p:nvSpPr>
+        <p:spPr/>
+      </p:sp>
+    </p:spTree>
+  </p:cSld>
+  <p:clrMapOvr>
+    <a:masterClrMapping/>
+  </p:clrMapOvr>
+</p:notes>
+</file>
+
+<file path=ppt/notesSlides/notesSlide21.xml><?xml version="1.0" encoding="utf-8"?>
+<p:notes xmlns:a="http://schemas.openxmlformats.org/drawingml/2006/main" xmlns:p="http://schemas.openxmlformats.org/presentationml/2006/main" xmlns:r="http://schemas.openxmlformats.org/officeDocument/2006/relationships">
+  <p:cSld>
+    <p:spTree>
+      <p:nvGrpSpPr>
+        <p:cNvPr id="1" name=""/>
+        <p:cNvGrpSpPr/>
+        <p:nvPr/>
+      </p:nvGrpSpPr>
+      <p:grpSpPr>
+        <a:xfrm>
+          <a:off x="0" y="0"/>
+          <a:ext cx="0" cy="0"/>
+          <a:chOff x="0" y="0"/>
+          <a:chExt cx="0" cy="0"/>
+        </a:xfrm>
+      </p:grpSpPr>
+      <p:sp>
+        <p:nvSpPr>
+          <p:cNvPr id="2" name="Slide Image Placeholder 1"/>
+          <p:cNvSpPr>
+            <a:spLocks noGrp="1"/>
+          </p:cNvSpPr>
+          <p:nvPr>
+            <p:ph type="sldImg" idx="2"/>
+          </p:nvPr>
+        </p:nvSpPr>
+        <p:spPr/>
+      </p:sp>
+      <p:sp>
+        <p:nvSpPr>
+          <p:cNvPr id="3" name="Notes Placeholder 2"/>
+          <p:cNvSpPr>
+            <a:spLocks noGrp="1"/>
+          </p:cNvSpPr>
+          <p:nvPr>
+            <p:ph type="body" idx="3" sz="quarter"/>
+          </p:nvPr>
+        </p:nvSpPr>
+        <p:spPr/>
+        <p:txBody>
+          <a:bodyPr/>
+          <a:lstStyle/>
+          <a:p>
+            <a:r>
+              <a:t>This is the slide where 'agents in the loop' becomes 'humans still in the loop when it counts.'</a:t>
+            </a:r>
+          </a:p>
+          <a:p/>
+          <a:p>
+            <a:r>
+              <a:t>Walk the screenshot:</a:t>
+            </a:r>
+          </a:p>
+          <a:p>
+            <a:r>
+              <a:t>  - pytest result: 160 passing, 22 failing</a:t>
+            </a:r>
+          </a:p>
+          <a:p>
+            <a:r>
+              <a:t>  - karen identifies: '22 failures — all pre-existing test bugs from     the unit-test-writer (wrong kwargs, wrong provider expectations,     test design mismatches)'</a:t>
+            </a:r>
+          </a:p>
+          <a:p>
+            <a:r>
+              <a:t>  - Karen presents options. The human picked Option C — accept the     pre-existing failures, proceed.</a:t>
+            </a:r>
+          </a:p>
+          <a:p/>
+          <a:p>
+            <a:r>
+              <a:t>What to say:</a:t>
+            </a:r>
+          </a:p>
+          <a:p>
+            <a:r>
+              <a:t>'Karen could have looped forever trying to fix unit-test-writer's bugs. Instead, she recognized the failure pattern, escalated with options, and let me make the call. This is the difference between an autonomous agent that wastes 20 minutes and a harness that knows when to ask.'</a:t>
+            </a:r>
+          </a:p>
+          <a:p/>
+          <a:p>
+            <a:r>
+              <a:t>Optional follow-up: the 22 pre-existing bugs got logged in PROBLEMS.md and PLAN.md for a future run to address. Nothing got swept under the rug.</a:t>
+            </a:r>
+          </a:p>
+        </p:txBody>
+      </p:sp>
+      <p:sp>
+        <p:nvSpPr>
+          <p:cNvPr id="4" name="Slide Number Placeholder 3"/>
+          <p:cNvSpPr>
+            <a:spLocks noGrp="1"/>
+          </p:cNvSpPr>
+          <p:nvPr>
+            <p:ph type="sldNum" idx="5" sz="quarter"/>
+          </p:nvPr>
+        </p:nvSpPr>
+        <p:spPr/>
+      </p:sp>
+    </p:spTree>
+  </p:cSld>
+  <p:clrMapOvr>
+    <a:masterClrMapping/>
+  </p:clrMapOvr>
+</p:notes>
+</file>
+
+<file path=ppt/notesSlides/notesSlide22.xml><?xml version="1.0" encoding="utf-8"?>
+<p:notes xmlns:a="http://schemas.openxmlformats.org/drawingml/2006/main" xmlns:p="http://schemas.openxmlformats.org/presentationml/2006/main" xmlns:r="http://schemas.openxmlformats.org/officeDocument/2006/relationships">
+  <p:cSld>
+    <p:spTree>
+      <p:nvGrpSpPr>
+        <p:cNvPr id="1" name=""/>
+        <p:cNvGrpSpPr/>
+        <p:nvPr/>
+      </p:nvGrpSpPr>
+      <p:grpSpPr>
+        <a:xfrm>
+          <a:off x="0" y="0"/>
+          <a:ext cx="0" cy="0"/>
+          <a:chOff x="0" y="0"/>
+          <a:chExt cx="0" cy="0"/>
+        </a:xfrm>
+      </p:grpSpPr>
+      <p:sp>
+        <p:nvSpPr>
+          <p:cNvPr id="2" name="Slide Image Placeholder 1"/>
+          <p:cNvSpPr>
+            <a:spLocks noGrp="1"/>
+          </p:cNvSpPr>
+          <p:nvPr>
+            <p:ph type="sldImg" idx="2"/>
+          </p:nvPr>
+        </p:nvSpPr>
+        <p:spPr/>
+      </p:sp>
+      <p:sp>
+        <p:nvSpPr>
+          <p:cNvPr id="3" name="Notes Placeholder 2"/>
+          <p:cNvSpPr>
+            <a:spLocks noGrp="1"/>
+          </p:cNvSpPr>
+          <p:nvPr>
+            <p:ph type="body" idx="3" sz="quarter"/>
+          </p:nvPr>
+        </p:nvSpPr>
+        <p:spPr/>
+        <p:txBody>
+          <a:bodyPr/>
+          <a:lstStyle/>
+          <a:p>
+            <a:r>
+              <a:t>This is the money shot. Don't talk over it for the first ten seconds — let people read.</a:t>
+            </a:r>
+          </a:p>
+          <a:p/>
+          <a:p>
+            <a:r>
+              <a:t>When you talk, hit the rows that matter:</a:t>
+            </a:r>
+          </a:p>
+          <a:p>
+            <a:r>
+              <a:t>  - 'TDD red phase: 182 tests written BEFORE implementation. That's     the test-immutability hook earning its keep — agents wrote tests     first, then code to make them pass.'</a:t>
+            </a:r>
+          </a:p>
+          <a:p>
+            <a:r>
+              <a:t>  - 'Parallel + sequential split: the orchestrator decided which work     was safe to parallelize. P1/P2 groups (types, core, providers) in     parallel. S1/S2 (cli, entrypoint) sequential because they depend     on the others.'</a:t>
+            </a:r>
+          </a:p>
+          <a:p>
+            <a:r>
+              <a:t>  - 'Karen: PARTIAL. Why partial and not PASS? She flagged a     .gitignore hiding src/, plus a provider-unknown design note.     Both legitimate, both reviewable.'</a:t>
+            </a:r>
+          </a:p>
+          <a:p>
+            <a:r>
+              <a:t>  - 'Security review: two medium items. SR-1 (UnicodeDecodeError in     Stripe) fixed in the same run. SR-2 (secret visible in process     arg list) documented in PLAN.md for follow-up. Neither shipped     silently.'</a:t>
+            </a:r>
+          </a:p>
+          <a:p/>
+          <a:p>
+            <a:r>
+              <a:t>Land the closer:</a:t>
+            </a:r>
+          </a:p>
+          <a:p>
+            <a:r>
+              <a:t>'30 minutes, 13 seconds. Two commits, PR open. Real working library. This is what the green column of slide 12 actually looks like in wall-clock time.'</a:t>
+            </a:r>
+          </a:p>
+        </p:txBody>
+      </p:sp>
+      <p:sp>
+        <p:nvSpPr>
+          <p:cNvPr id="4" name="Slide Number Placeholder 3"/>
+          <p:cNvSpPr>
+            <a:spLocks noGrp="1"/>
+          </p:cNvSpPr>
+          <p:nvPr>
+            <p:ph type="sldNum" idx="5" sz="quarter"/>
+          </p:nvPr>
+        </p:nvSpPr>
+        <p:spPr/>
+      </p:sp>
+    </p:spTree>
+  </p:cSld>
+  <p:clrMapOvr>
+    <a:masterClrMapping/>
+  </p:clrMapOvr>
+</p:notes>
+</file>
+
+<file path=ppt/notesSlides/notesSlide23.xml><?xml version="1.0" encoding="utf-8"?>
+<p:notes xmlns:a="http://schemas.openxmlformats.org/drawingml/2006/main" xmlns:p="http://schemas.openxmlformats.org/presentationml/2006/main" xmlns:r="http://schemas.openxmlformats.org/officeDocument/2006/relationships">
+  <p:cSld>
+    <p:spTree>
+      <p:nvGrpSpPr>
+        <p:cNvPr id="1" name=""/>
+        <p:cNvGrpSpPr/>
+        <p:nvPr/>
+      </p:nvGrpSpPr>
+      <p:grpSpPr>
+        <a:xfrm>
+          <a:off x="0" y="0"/>
+          <a:ext cx="0" cy="0"/>
+          <a:chOff x="0" y="0"/>
+          <a:chExt cx="0" cy="0"/>
+        </a:xfrm>
+      </p:grpSpPr>
+      <p:sp>
+        <p:nvSpPr>
+          <p:cNvPr id="2" name="Slide Image Placeholder 1"/>
+          <p:cNvSpPr>
+            <a:spLocks noGrp="1"/>
+          </p:cNvSpPr>
+          <p:nvPr>
+            <p:ph type="sldImg" idx="2"/>
+          </p:nvPr>
+        </p:nvSpPr>
+        <p:spPr/>
+      </p:sp>
+      <p:sp>
+        <p:nvSpPr>
+          <p:cNvPr id="3" name="Notes Placeholder 2"/>
+          <p:cNvSpPr>
+            <a:spLocks noGrp="1"/>
+          </p:cNvSpPr>
+          <p:nvPr>
+            <p:ph type="body" idx="3" sz="quarter"/>
+          </p:nvPr>
+        </p:nvSpPr>
+        <p:spPr/>
+        <p:txBody>
+          <a:bodyPr/>
+          <a:lstStyle/>
+          <a:p>
+            <a:r>
+              <a:t>This slide exists for the skeptics. On slide 8 you claimed an audit trail. Here it is.</a:t>
+            </a:r>
+          </a:p>
+          <a:p/>
+          <a:p>
+            <a:r>
+              <a:t>What to say:</a:t>
+            </a:r>
+          </a:p>
+          <a:p>
+            <a:r>
+              <a:t>'These are excerpts from sessions/20260520-2116/session_log.json. Every tool call the agents made during the run got appended to this file. Bash commands, file reads, file writes, sub-agent invocations, everything. When something goes weird in a run — and things do go weird — this is the file you grep.'</a:t>
+            </a:r>
+          </a:p>
+          <a:p/>
+          <a:p>
+            <a:r>
+              <a:t>If asked what you actually do with the log:</a:t>
+            </a:r>
+          </a:p>
+          <a:p>
+            <a:r>
+              <a:t>  - Replay a run mentally without re-running it</a:t>
+            </a:r>
+          </a:p>
+          <a:p>
+            <a:r>
+              <a:t>  - Find which agent touched a specific file</a:t>
+            </a:r>
+          </a:p>
+          <a:p>
+            <a:r>
+              <a:t>  - Measure how often a given tool gets called</a:t>
+            </a:r>
+          </a:p>
+          <a:p>
+            <a:r>
+              <a:t>  - Catch agents trying things they shouldn't (the hooks block most,     but the log shows the attempt)</a:t>
+            </a:r>
+          </a:p>
+          <a:p/>
+          <a:p>
+            <a:r>
+              <a:t>If the audience is non-technical, you can soft-pedal this slide: 'For the engineers in the room — yes, every action is logged. Moving on.' and skip the deep-dive.</a:t>
             </a:r>
           </a:p>
         </p:txBody>
@@ -5928,7 +6779,7 @@
                 </a:solidFill>
                 <a:latin typeface="Segoe UI"/>
               </a:rPr>
-              <a:t>10 / 14</a:t>
+              <a:t>10 / 23</a:t>
             </a:r>
           </a:p>
         </p:txBody>
@@ -6698,7 +7549,7 @@
                 </a:solidFill>
                 <a:latin typeface="Segoe UI"/>
               </a:rPr>
-              <a:t>11 / 14</a:t>
+              <a:t>11 / 23</a:t>
             </a:r>
           </a:p>
         </p:txBody>
@@ -7548,7 +8399,7 @@
                 </a:solidFill>
                 <a:latin typeface="Segoe UI"/>
               </a:rPr>
-              <a:t>12 / 14</a:t>
+              <a:t>12 / 23</a:t>
             </a:r>
           </a:p>
         </p:txBody>
@@ -8411,7 +9262,7 @@
                 </a:solidFill>
                 <a:latin typeface="Segoe UI"/>
               </a:rPr>
-              <a:t>13 / 14</a:t>
+              <a:t>13 / 23</a:t>
             </a:r>
           </a:p>
         </p:txBody>
@@ -9156,7 +10007,2394 @@
                 </a:solidFill>
                 <a:latin typeface="Segoe UI"/>
               </a:rPr>
-              <a:t>14 / 14</a:t>
+              <a:t>14 / 23</a:t>
+            </a:r>
+          </a:p>
+        </p:txBody>
+      </p:sp>
+    </p:spTree>
+  </p:cSld>
+  <p:clrMapOvr>
+    <a:masterClrMapping/>
+  </p:clrMapOvr>
+</p:sld>
+</file>
+
+<file path=ppt/slides/slide15.xml><?xml version="1.0" encoding="utf-8"?>
+<p:sld xmlns:a="http://schemas.openxmlformats.org/drawingml/2006/main" xmlns:p="http://schemas.openxmlformats.org/presentationml/2006/main" xmlns:r="http://schemas.openxmlformats.org/officeDocument/2006/relationships">
+  <p:cSld>
+    <p:spTree>
+      <p:nvGrpSpPr>
+        <p:cNvPr id="1" name=""/>
+        <p:cNvGrpSpPr/>
+        <p:nvPr/>
+      </p:nvGrpSpPr>
+      <p:grpSpPr/>
+      <p:sp>
+        <p:nvSpPr>
+          <p:cNvPr id="2" name="Rectangle 1"/>
+          <p:cNvSpPr/>
+          <p:nvPr/>
+        </p:nvSpPr>
+        <p:spPr>
+          <a:xfrm>
+            <a:off x="0" y="0"/>
+            <a:ext cx="12191695" cy="6858000"/>
+          </a:xfrm>
+          <a:prstGeom prst="rect">
+            <a:avLst/>
+          </a:prstGeom>
+          <a:solidFill>
+            <a:srgbClr val="0F141A"/>
+          </a:solidFill>
+          <a:ln>
+            <a:noFill/>
+          </a:ln>
+          <a:effectLst/>
+        </p:spPr>
+        <p:style>
+          <a:lnRef idx="1">
+            <a:schemeClr val="accent1"/>
+          </a:lnRef>
+          <a:fillRef idx="3">
+            <a:schemeClr val="accent1"/>
+          </a:fillRef>
+          <a:effectRef idx="2">
+            <a:schemeClr val="accent1"/>
+          </a:effectRef>
+          <a:fontRef idx="minor">
+            <a:schemeClr val="lt1"/>
+          </a:fontRef>
+        </p:style>
+        <p:txBody>
+          <a:bodyPr rtlCol="0" anchor="ctr"/>
+          <a:lstStyle/>
+          <a:p>
+            <a:pPr algn="ctr"/>
+          </a:p>
+        </p:txBody>
+      </p:sp>
+      <p:sp>
+        <p:nvSpPr>
+          <p:cNvPr id="3" name="TextBox 2"/>
+          <p:cNvSpPr txBox="1"/>
+          <p:nvPr/>
+        </p:nvSpPr>
+        <p:spPr>
+          <a:xfrm>
+            <a:off x="457200" y="1828800"/>
+            <a:ext cx="11247120" cy="457200"/>
+          </a:xfrm>
+          <a:prstGeom prst="rect">
+            <a:avLst/>
+          </a:prstGeom>
+          <a:noFill/>
+        </p:spPr>
+        <p:txBody>
+          <a:bodyPr wrap="square" lIns="45720" rIns="45720" tIns="18288" bIns="18288">
+            <a:spAutoFit/>
+          </a:bodyPr>
+          <a:lstStyle/>
+          <a:p>
+            <a:pPr algn="ctr"/>
+            <a:r>
+              <a:rPr sz="1800" b="1">
+                <a:solidFill>
+                  <a:srgbClr val="6EE7B7"/>
+                </a:solidFill>
+                <a:latin typeface="Segoe UI"/>
+              </a:rPr>
+              <a:t>APPENDIX</a:t>
+            </a:r>
+          </a:p>
+        </p:txBody>
+      </p:sp>
+      <p:sp>
+        <p:nvSpPr>
+          <p:cNvPr id="4" name="TextBox 3"/>
+          <p:cNvSpPr txBox="1"/>
+          <p:nvPr/>
+        </p:nvSpPr>
+        <p:spPr>
+          <a:xfrm>
+            <a:off x="457200" y="2331720"/>
+            <a:ext cx="11247120" cy="1097280"/>
+          </a:xfrm>
+          <a:prstGeom prst="rect">
+            <a:avLst/>
+          </a:prstGeom>
+          <a:noFill/>
+        </p:spPr>
+        <p:txBody>
+          <a:bodyPr wrap="square" lIns="45720" rIns="45720" tIns="18288" bIns="18288">
+            <a:spAutoFit/>
+          </a:bodyPr>
+          <a:lstStyle/>
+          <a:p>
+            <a:pPr algn="ctr"/>
+            <a:r>
+              <a:rPr sz="4400" b="1">
+                <a:solidFill>
+                  <a:srgbClr val="E8ECF1"/>
+                </a:solidFill>
+                <a:latin typeface="Segoe UI"/>
+              </a:rPr>
+              <a:t>Case study: /run builds webhooksig</a:t>
+            </a:r>
+          </a:p>
+        </p:txBody>
+      </p:sp>
+      <p:sp>
+        <p:nvSpPr>
+          <p:cNvPr id="5" name="TextBox 4"/>
+          <p:cNvSpPr txBox="1"/>
+          <p:nvPr/>
+        </p:nvSpPr>
+        <p:spPr>
+          <a:xfrm>
+            <a:off x="457200" y="3474720"/>
+            <a:ext cx="11247120" cy="457200"/>
+          </a:xfrm>
+          <a:prstGeom prst="rect">
+            <a:avLst/>
+          </a:prstGeom>
+          <a:noFill/>
+        </p:spPr>
+        <p:txBody>
+          <a:bodyPr wrap="square" lIns="45720" rIns="45720" tIns="18288" bIns="18288">
+            <a:spAutoFit/>
+          </a:bodyPr>
+          <a:lstStyle/>
+          <a:p>
+            <a:pPr algn="ctr"/>
+            <a:r>
+              <a:rPr sz="1800" b="0">
+                <a:solidFill>
+                  <a:srgbClr val="9AA3AF"/>
+                </a:solidFill>
+                <a:latin typeface="Segoe UI"/>
+              </a:rPr>
+              <a:t>Idea → merged PR in 30 m 13 s. Every stage. Real receipts.</a:t>
+            </a:r>
+          </a:p>
+        </p:txBody>
+      </p:sp>
+      <p:sp>
+        <p:nvSpPr>
+          <p:cNvPr id="6" name="Rounded Rectangle 5"/>
+          <p:cNvSpPr/>
+          <p:nvPr/>
+        </p:nvSpPr>
+        <p:spPr>
+          <a:xfrm>
+            <a:off x="685800" y="4389120"/>
+            <a:ext cx="2697480" cy="1097280"/>
+          </a:xfrm>
+          <a:prstGeom prst="roundRect">
+            <a:avLst/>
+          </a:prstGeom>
+          <a:solidFill>
+            <a:srgbClr val="181F2A"/>
+          </a:solidFill>
+          <a:ln w="9525">
+            <a:solidFill>
+              <a:srgbClr val="34A87E"/>
+            </a:solidFill>
+          </a:ln>
+          <a:effectLst/>
+        </p:spPr>
+        <p:style>
+          <a:lnRef idx="1">
+            <a:schemeClr val="accent1"/>
+          </a:lnRef>
+          <a:fillRef idx="3">
+            <a:schemeClr val="accent1"/>
+          </a:fillRef>
+          <a:effectRef idx="2">
+            <a:schemeClr val="accent1"/>
+          </a:effectRef>
+          <a:fontRef idx="minor">
+            <a:schemeClr val="lt1"/>
+          </a:fontRef>
+        </p:style>
+        <p:txBody>
+          <a:bodyPr rtlCol="0" anchor="ctr"/>
+          <a:lstStyle/>
+          <a:p>
+            <a:pPr algn="ctr"/>
+          </a:p>
+        </p:txBody>
+      </p:sp>
+      <p:sp>
+        <p:nvSpPr>
+          <p:cNvPr id="7" name="TextBox 6"/>
+          <p:cNvSpPr txBox="1"/>
+          <p:nvPr/>
+        </p:nvSpPr>
+        <p:spPr>
+          <a:xfrm>
+            <a:off x="685800" y="4480560"/>
+            <a:ext cx="2697480" cy="548640"/>
+          </a:xfrm>
+          <a:prstGeom prst="rect">
+            <a:avLst/>
+          </a:prstGeom>
+          <a:noFill/>
+        </p:spPr>
+        <p:txBody>
+          <a:bodyPr wrap="square" lIns="45720" rIns="45720" tIns="18288" bIns="18288">
+            <a:spAutoFit/>
+          </a:bodyPr>
+          <a:lstStyle/>
+          <a:p>
+            <a:pPr algn="ctr"/>
+            <a:r>
+              <a:rPr sz="2800" b="1">
+                <a:solidFill>
+                  <a:srgbClr val="6EE7B7"/>
+                </a:solidFill>
+                <a:latin typeface="Segoe UI"/>
+              </a:rPr>
+              <a:t>30m 13s</a:t>
+            </a:r>
+          </a:p>
+        </p:txBody>
+      </p:sp>
+      <p:sp>
+        <p:nvSpPr>
+          <p:cNvPr id="8" name="TextBox 7"/>
+          <p:cNvSpPr txBox="1"/>
+          <p:nvPr/>
+        </p:nvSpPr>
+        <p:spPr>
+          <a:xfrm>
+            <a:off x="685800" y="5029200"/>
+            <a:ext cx="2697480" cy="365760"/>
+          </a:xfrm>
+          <a:prstGeom prst="rect">
+            <a:avLst/>
+          </a:prstGeom>
+          <a:noFill/>
+        </p:spPr>
+        <p:txBody>
+          <a:bodyPr wrap="square" lIns="45720" rIns="45720" tIns="18288" bIns="18288">
+            <a:spAutoFit/>
+          </a:bodyPr>
+          <a:lstStyle/>
+          <a:p>
+            <a:pPr algn="ctr"/>
+            <a:r>
+              <a:rPr sz="1100" b="0">
+                <a:solidFill>
+                  <a:srgbClr val="9AA3AF"/>
+                </a:solidFill>
+                <a:latin typeface="Segoe UI"/>
+              </a:rPr>
+              <a:t>wall clock</a:t>
+            </a:r>
+          </a:p>
+        </p:txBody>
+      </p:sp>
+      <p:sp>
+        <p:nvSpPr>
+          <p:cNvPr id="9" name="Rounded Rectangle 8"/>
+          <p:cNvSpPr/>
+          <p:nvPr/>
+        </p:nvSpPr>
+        <p:spPr>
+          <a:xfrm>
+            <a:off x="3474720" y="4389120"/>
+            <a:ext cx="2697480" cy="1097280"/>
+          </a:xfrm>
+          <a:prstGeom prst="roundRect">
+            <a:avLst/>
+          </a:prstGeom>
+          <a:solidFill>
+            <a:srgbClr val="181F2A"/>
+          </a:solidFill>
+          <a:ln w="9525">
+            <a:solidFill>
+              <a:srgbClr val="34A87E"/>
+            </a:solidFill>
+          </a:ln>
+          <a:effectLst/>
+        </p:spPr>
+        <p:style>
+          <a:lnRef idx="1">
+            <a:schemeClr val="accent1"/>
+          </a:lnRef>
+          <a:fillRef idx="3">
+            <a:schemeClr val="accent1"/>
+          </a:fillRef>
+          <a:effectRef idx="2">
+            <a:schemeClr val="accent1"/>
+          </a:effectRef>
+          <a:fontRef idx="minor">
+            <a:schemeClr val="lt1"/>
+          </a:fontRef>
+        </p:style>
+        <p:txBody>
+          <a:bodyPr rtlCol="0" anchor="ctr"/>
+          <a:lstStyle/>
+          <a:p>
+            <a:pPr algn="ctr"/>
+          </a:p>
+        </p:txBody>
+      </p:sp>
+      <p:sp>
+        <p:nvSpPr>
+          <p:cNvPr id="10" name="TextBox 9"/>
+          <p:cNvSpPr txBox="1"/>
+          <p:nvPr/>
+        </p:nvSpPr>
+        <p:spPr>
+          <a:xfrm>
+            <a:off x="3474720" y="4480560"/>
+            <a:ext cx="2697480" cy="548640"/>
+          </a:xfrm>
+          <a:prstGeom prst="rect">
+            <a:avLst/>
+          </a:prstGeom>
+          <a:noFill/>
+        </p:spPr>
+        <p:txBody>
+          <a:bodyPr wrap="square" lIns="45720" rIns="45720" tIns="18288" bIns="18288">
+            <a:spAutoFit/>
+          </a:bodyPr>
+          <a:lstStyle/>
+          <a:p>
+            <a:pPr algn="ctr"/>
+            <a:r>
+              <a:rPr sz="2800" b="1">
+                <a:solidFill>
+                  <a:srgbClr val="F5C249"/>
+                </a:solidFill>
+                <a:latin typeface="Segoe UI"/>
+              </a:rPr>
+              <a:t>12</a:t>
+            </a:r>
+          </a:p>
+        </p:txBody>
+      </p:sp>
+      <p:sp>
+        <p:nvSpPr>
+          <p:cNvPr id="11" name="TextBox 10"/>
+          <p:cNvSpPr txBox="1"/>
+          <p:nvPr/>
+        </p:nvSpPr>
+        <p:spPr>
+          <a:xfrm>
+            <a:off x="3474720" y="5029200"/>
+            <a:ext cx="2697480" cy="365760"/>
+          </a:xfrm>
+          <a:prstGeom prst="rect">
+            <a:avLst/>
+          </a:prstGeom>
+          <a:noFill/>
+        </p:spPr>
+        <p:txBody>
+          <a:bodyPr wrap="square" lIns="45720" rIns="45720" tIns="18288" bIns="18288">
+            <a:spAutoFit/>
+          </a:bodyPr>
+          <a:lstStyle/>
+          <a:p>
+            <a:pPr algn="ctr"/>
+            <a:r>
+              <a:rPr sz="1100" b="0">
+                <a:solidFill>
+                  <a:srgbClr val="9AA3AF"/>
+                </a:solidFill>
+                <a:latin typeface="Segoe UI"/>
+              </a:rPr>
+              <a:t>agents invoked</a:t>
+            </a:r>
+          </a:p>
+        </p:txBody>
+      </p:sp>
+      <p:sp>
+        <p:nvSpPr>
+          <p:cNvPr id="12" name="Rounded Rectangle 11"/>
+          <p:cNvSpPr/>
+          <p:nvPr/>
+        </p:nvSpPr>
+        <p:spPr>
+          <a:xfrm>
+            <a:off x="6263640" y="4389120"/>
+            <a:ext cx="2697480" cy="1097280"/>
+          </a:xfrm>
+          <a:prstGeom prst="roundRect">
+            <a:avLst/>
+          </a:prstGeom>
+          <a:solidFill>
+            <a:srgbClr val="181F2A"/>
+          </a:solidFill>
+          <a:ln w="9525">
+            <a:solidFill>
+              <a:srgbClr val="34A87E"/>
+            </a:solidFill>
+          </a:ln>
+          <a:effectLst/>
+        </p:spPr>
+        <p:style>
+          <a:lnRef idx="1">
+            <a:schemeClr val="accent1"/>
+          </a:lnRef>
+          <a:fillRef idx="3">
+            <a:schemeClr val="accent1"/>
+          </a:fillRef>
+          <a:effectRef idx="2">
+            <a:schemeClr val="accent1"/>
+          </a:effectRef>
+          <a:fontRef idx="minor">
+            <a:schemeClr val="lt1"/>
+          </a:fontRef>
+        </p:style>
+        <p:txBody>
+          <a:bodyPr rtlCol="0" anchor="ctr"/>
+          <a:lstStyle/>
+          <a:p>
+            <a:pPr algn="ctr"/>
+          </a:p>
+        </p:txBody>
+      </p:sp>
+      <p:sp>
+        <p:nvSpPr>
+          <p:cNvPr id="13" name="TextBox 12"/>
+          <p:cNvSpPr txBox="1"/>
+          <p:nvPr/>
+        </p:nvSpPr>
+        <p:spPr>
+          <a:xfrm>
+            <a:off x="6263640" y="4480560"/>
+            <a:ext cx="2697480" cy="548640"/>
+          </a:xfrm>
+          <a:prstGeom prst="rect">
+            <a:avLst/>
+          </a:prstGeom>
+          <a:noFill/>
+        </p:spPr>
+        <p:txBody>
+          <a:bodyPr wrap="square" lIns="45720" rIns="45720" tIns="18288" bIns="18288">
+            <a:spAutoFit/>
+          </a:bodyPr>
+          <a:lstStyle/>
+          <a:p>
+            <a:pPr algn="ctr"/>
+            <a:r>
+              <a:rPr sz="2800" b="1">
+                <a:solidFill>
+                  <a:srgbClr val="6EE7B7"/>
+                </a:solidFill>
+                <a:latin typeface="Segoe UI"/>
+              </a:rPr>
+              <a:t>182</a:t>
+            </a:r>
+          </a:p>
+        </p:txBody>
+      </p:sp>
+      <p:sp>
+        <p:nvSpPr>
+          <p:cNvPr id="14" name="TextBox 13"/>
+          <p:cNvSpPr txBox="1"/>
+          <p:nvPr/>
+        </p:nvSpPr>
+        <p:spPr>
+          <a:xfrm>
+            <a:off x="6263640" y="5029200"/>
+            <a:ext cx="2697480" cy="365760"/>
+          </a:xfrm>
+          <a:prstGeom prst="rect">
+            <a:avLst/>
+          </a:prstGeom>
+          <a:noFill/>
+        </p:spPr>
+        <p:txBody>
+          <a:bodyPr wrap="square" lIns="45720" rIns="45720" tIns="18288" bIns="18288">
+            <a:spAutoFit/>
+          </a:bodyPr>
+          <a:lstStyle/>
+          <a:p>
+            <a:pPr algn="ctr"/>
+            <a:r>
+              <a:rPr sz="1100" b="0">
+                <a:solidFill>
+                  <a:srgbClr val="9AA3AF"/>
+                </a:solidFill>
+                <a:latin typeface="Segoe UI"/>
+              </a:rPr>
+              <a:t>tests written</a:t>
+            </a:r>
+          </a:p>
+        </p:txBody>
+      </p:sp>
+      <p:sp>
+        <p:nvSpPr>
+          <p:cNvPr id="15" name="Rounded Rectangle 14"/>
+          <p:cNvSpPr/>
+          <p:nvPr/>
+        </p:nvSpPr>
+        <p:spPr>
+          <a:xfrm>
+            <a:off x="9052560" y="4389120"/>
+            <a:ext cx="2697480" cy="1097280"/>
+          </a:xfrm>
+          <a:prstGeom prst="roundRect">
+            <a:avLst/>
+          </a:prstGeom>
+          <a:solidFill>
+            <a:srgbClr val="181F2A"/>
+          </a:solidFill>
+          <a:ln w="9525">
+            <a:solidFill>
+              <a:srgbClr val="34A87E"/>
+            </a:solidFill>
+          </a:ln>
+          <a:effectLst/>
+        </p:spPr>
+        <p:style>
+          <a:lnRef idx="1">
+            <a:schemeClr val="accent1"/>
+          </a:lnRef>
+          <a:fillRef idx="3">
+            <a:schemeClr val="accent1"/>
+          </a:fillRef>
+          <a:effectRef idx="2">
+            <a:schemeClr val="accent1"/>
+          </a:effectRef>
+          <a:fontRef idx="minor">
+            <a:schemeClr val="lt1"/>
+          </a:fontRef>
+        </p:style>
+        <p:txBody>
+          <a:bodyPr rtlCol="0" anchor="ctr"/>
+          <a:lstStyle/>
+          <a:p>
+            <a:pPr algn="ctr"/>
+          </a:p>
+        </p:txBody>
+      </p:sp>
+      <p:sp>
+        <p:nvSpPr>
+          <p:cNvPr id="16" name="TextBox 15"/>
+          <p:cNvSpPr txBox="1"/>
+          <p:nvPr/>
+        </p:nvSpPr>
+        <p:spPr>
+          <a:xfrm>
+            <a:off x="9052560" y="4480560"/>
+            <a:ext cx="2697480" cy="548640"/>
+          </a:xfrm>
+          <a:prstGeom prst="rect">
+            <a:avLst/>
+          </a:prstGeom>
+          <a:noFill/>
+        </p:spPr>
+        <p:txBody>
+          <a:bodyPr wrap="square" lIns="45720" rIns="45720" tIns="18288" bIns="18288">
+            <a:spAutoFit/>
+          </a:bodyPr>
+          <a:lstStyle/>
+          <a:p>
+            <a:pPr algn="ctr"/>
+            <a:r>
+              <a:rPr sz="2800" b="1">
+                <a:solidFill>
+                  <a:srgbClr val="F87271"/>
+                </a:solidFill>
+                <a:latin typeface="Segoe UI"/>
+              </a:rPr>
+              <a:t>$0.05</a:t>
+            </a:r>
+          </a:p>
+        </p:txBody>
+      </p:sp>
+      <p:sp>
+        <p:nvSpPr>
+          <p:cNvPr id="17" name="TextBox 16"/>
+          <p:cNvSpPr txBox="1"/>
+          <p:nvPr/>
+        </p:nvSpPr>
+        <p:spPr>
+          <a:xfrm>
+            <a:off x="9052560" y="5029200"/>
+            <a:ext cx="2697480" cy="365760"/>
+          </a:xfrm>
+          <a:prstGeom prst="rect">
+            <a:avLst/>
+          </a:prstGeom>
+          <a:noFill/>
+        </p:spPr>
+        <p:txBody>
+          <a:bodyPr wrap="square" lIns="45720" rIns="45720" tIns="18288" bIns="18288">
+            <a:spAutoFit/>
+          </a:bodyPr>
+          <a:lstStyle/>
+          <a:p>
+            <a:pPr algn="ctr"/>
+            <a:r>
+              <a:rPr sz="1100" b="0">
+                <a:solidFill>
+                  <a:srgbClr val="9AA3AF"/>
+                </a:solidFill>
+                <a:latin typeface="Segoe UI"/>
+              </a:rPr>
+              <a:t>approx token cost</a:t>
+            </a:r>
+          </a:p>
+        </p:txBody>
+      </p:sp>
+      <p:sp>
+        <p:nvSpPr>
+          <p:cNvPr id="18" name="TextBox 17"/>
+          <p:cNvSpPr txBox="1"/>
+          <p:nvPr/>
+        </p:nvSpPr>
+        <p:spPr>
+          <a:xfrm>
+            <a:off x="457200" y="5852160"/>
+            <a:ext cx="11247120" cy="365760"/>
+          </a:xfrm>
+          <a:prstGeom prst="rect">
+            <a:avLst/>
+          </a:prstGeom>
+          <a:noFill/>
+        </p:spPr>
+        <p:txBody>
+          <a:bodyPr wrap="square" lIns="45720" rIns="45720" tIns="18288" bIns="18288">
+            <a:spAutoFit/>
+          </a:bodyPr>
+          <a:lstStyle/>
+          <a:p>
+            <a:pPr algn="ctr"/>
+            <a:r>
+              <a:rPr sz="1000" b="0">
+                <a:solidFill>
+                  <a:srgbClr val="9AA3AF"/>
+                </a:solidFill>
+                <a:latin typeface="Consolas"/>
+              </a:rPr>
+              <a:t>Full screen recording available alongside this deck: pptx_refs/Screen Recording 2026-05-22 at 10.51.37 AM.mov</a:t>
+            </a:r>
+          </a:p>
+        </p:txBody>
+      </p:sp>
+      <p:sp>
+        <p:nvSpPr>
+          <p:cNvPr id="19" name="TextBox 18"/>
+          <p:cNvSpPr txBox="1"/>
+          <p:nvPr/>
+        </p:nvSpPr>
+        <p:spPr>
+          <a:xfrm>
+            <a:off x="457200" y="6400800"/>
+            <a:ext cx="5486400" cy="274320"/>
+          </a:xfrm>
+          <a:prstGeom prst="rect">
+            <a:avLst/>
+          </a:prstGeom>
+          <a:noFill/>
+        </p:spPr>
+        <p:txBody>
+          <a:bodyPr wrap="square" lIns="45720" rIns="45720" tIns="18288" bIns="18288">
+            <a:spAutoFit/>
+          </a:bodyPr>
+          <a:lstStyle/>
+          <a:p>
+            <a:pPr algn="l"/>
+            <a:r>
+              <a:rPr sz="1000" b="0">
+                <a:solidFill>
+                  <a:srgbClr val="9AA3AF"/>
+                </a:solidFill>
+                <a:latin typeface="Segoe UI"/>
+              </a:rPr>
+              <a:t>EFF-IT  —  A Claude Code harness</a:t>
+            </a:r>
+          </a:p>
+        </p:txBody>
+      </p:sp>
+      <p:sp>
+        <p:nvSpPr>
+          <p:cNvPr id="20" name="TextBox 19"/>
+          <p:cNvSpPr txBox="1"/>
+          <p:nvPr/>
+        </p:nvSpPr>
+        <p:spPr>
+          <a:xfrm>
+            <a:off x="10515600" y="6400800"/>
+            <a:ext cx="1645920" cy="274320"/>
+          </a:xfrm>
+          <a:prstGeom prst="rect">
+            <a:avLst/>
+          </a:prstGeom>
+          <a:noFill/>
+        </p:spPr>
+        <p:txBody>
+          <a:bodyPr wrap="square" lIns="45720" rIns="45720" tIns="18288" bIns="18288">
+            <a:spAutoFit/>
+          </a:bodyPr>
+          <a:lstStyle/>
+          <a:p>
+            <a:pPr algn="r"/>
+            <a:r>
+              <a:rPr sz="1000" b="0">
+                <a:solidFill>
+                  <a:srgbClr val="9AA3AF"/>
+                </a:solidFill>
+                <a:latin typeface="Segoe UI"/>
+              </a:rPr>
+              <a:t>15 / 23</a:t>
+            </a:r>
+          </a:p>
+        </p:txBody>
+      </p:sp>
+    </p:spTree>
+  </p:cSld>
+  <p:clrMapOvr>
+    <a:masterClrMapping/>
+  </p:clrMapOvr>
+</p:sld>
+</file>
+
+<file path=ppt/slides/slide16.xml><?xml version="1.0" encoding="utf-8"?>
+<p:sld xmlns:a="http://schemas.openxmlformats.org/drawingml/2006/main" xmlns:p="http://schemas.openxmlformats.org/presentationml/2006/main" xmlns:r="http://schemas.openxmlformats.org/officeDocument/2006/relationships">
+  <p:cSld>
+    <p:spTree>
+      <p:nvGrpSpPr>
+        <p:cNvPr id="1" name=""/>
+        <p:cNvGrpSpPr/>
+        <p:nvPr/>
+      </p:nvGrpSpPr>
+      <p:grpSpPr/>
+      <p:sp>
+        <p:nvSpPr>
+          <p:cNvPr id="2" name="Rectangle 1"/>
+          <p:cNvSpPr/>
+          <p:nvPr/>
+        </p:nvSpPr>
+        <p:spPr>
+          <a:xfrm>
+            <a:off x="0" y="0"/>
+            <a:ext cx="12191695" cy="6858000"/>
+          </a:xfrm>
+          <a:prstGeom prst="rect">
+            <a:avLst/>
+          </a:prstGeom>
+          <a:solidFill>
+            <a:srgbClr val="0F141A"/>
+          </a:solidFill>
+          <a:ln>
+            <a:noFill/>
+          </a:ln>
+          <a:effectLst/>
+        </p:spPr>
+        <p:style>
+          <a:lnRef idx="1">
+            <a:schemeClr val="accent1"/>
+          </a:lnRef>
+          <a:fillRef idx="3">
+            <a:schemeClr val="accent1"/>
+          </a:fillRef>
+          <a:effectRef idx="2">
+            <a:schemeClr val="accent1"/>
+          </a:effectRef>
+          <a:fontRef idx="minor">
+            <a:schemeClr val="lt1"/>
+          </a:fontRef>
+        </p:style>
+        <p:txBody>
+          <a:bodyPr rtlCol="0" anchor="ctr"/>
+          <a:lstStyle/>
+          <a:p>
+            <a:pPr algn="ctr"/>
+          </a:p>
+        </p:txBody>
+      </p:sp>
+      <p:sp>
+        <p:nvSpPr>
+          <p:cNvPr id="3" name="Rectangle 2"/>
+          <p:cNvSpPr/>
+          <p:nvPr/>
+        </p:nvSpPr>
+        <p:spPr>
+          <a:xfrm>
+            <a:off x="457200" y="411480"/>
+            <a:ext cx="73152" cy="502920"/>
+          </a:xfrm>
+          <a:prstGeom prst="rect">
+            <a:avLst/>
+          </a:prstGeom>
+          <a:solidFill>
+            <a:srgbClr val="6EE7B7"/>
+          </a:solidFill>
+          <a:ln>
+            <a:noFill/>
+          </a:ln>
+          <a:effectLst/>
+        </p:spPr>
+        <p:style>
+          <a:lnRef idx="1">
+            <a:schemeClr val="accent1"/>
+          </a:lnRef>
+          <a:fillRef idx="3">
+            <a:schemeClr val="accent1"/>
+          </a:fillRef>
+          <a:effectRef idx="2">
+            <a:schemeClr val="accent1"/>
+          </a:effectRef>
+          <a:fontRef idx="minor">
+            <a:schemeClr val="lt1"/>
+          </a:fontRef>
+        </p:style>
+        <p:txBody>
+          <a:bodyPr rtlCol="0" anchor="ctr"/>
+          <a:lstStyle/>
+          <a:p>
+            <a:pPr algn="ctr"/>
+          </a:p>
+        </p:txBody>
+      </p:sp>
+      <p:sp>
+        <p:nvSpPr>
+          <p:cNvPr id="4" name="TextBox 3"/>
+          <p:cNvSpPr txBox="1"/>
+          <p:nvPr/>
+        </p:nvSpPr>
+        <p:spPr>
+          <a:xfrm>
+            <a:off x="685800" y="292608"/>
+            <a:ext cx="1828800" cy="365760"/>
+          </a:xfrm>
+          <a:prstGeom prst="rect">
+            <a:avLst/>
+          </a:prstGeom>
+          <a:noFill/>
+        </p:spPr>
+        <p:txBody>
+          <a:bodyPr wrap="square" lIns="45720" rIns="45720" tIns="18288" bIns="18288">
+            <a:spAutoFit/>
+          </a:bodyPr>
+          <a:lstStyle/>
+          <a:p>
+            <a:pPr algn="l"/>
+            <a:r>
+              <a:rPr sz="1100" b="1">
+                <a:solidFill>
+                  <a:srgbClr val="6EE7B7"/>
+                </a:solidFill>
+                <a:latin typeface="Segoe UI"/>
+              </a:rPr>
+              <a:t>APPENDIX · 1 / 8</a:t>
+            </a:r>
+          </a:p>
+        </p:txBody>
+      </p:sp>
+      <p:sp>
+        <p:nvSpPr>
+          <p:cNvPr id="5" name="TextBox 4"/>
+          <p:cNvSpPr txBox="1"/>
+          <p:nvPr/>
+        </p:nvSpPr>
+        <p:spPr>
+          <a:xfrm>
+            <a:off x="685800" y="594360"/>
+            <a:ext cx="10972800" cy="457200"/>
+          </a:xfrm>
+          <a:prstGeom prst="rect">
+            <a:avLst/>
+          </a:prstGeom>
+          <a:noFill/>
+        </p:spPr>
+        <p:txBody>
+          <a:bodyPr wrap="square" lIns="45720" rIns="45720" tIns="18288" bIns="18288">
+            <a:spAutoFit/>
+          </a:bodyPr>
+          <a:lstStyle/>
+          <a:p>
+            <a:pPr algn="l"/>
+            <a:r>
+              <a:rPr sz="2400" b="1">
+                <a:solidFill>
+                  <a:srgbClr val="E8ECF1"/>
+                </a:solidFill>
+                <a:latin typeface="Segoe UI"/>
+              </a:rPr>
+              <a:t>Step 0–1: Invocation + interrogation</a:t>
+            </a:r>
+          </a:p>
+        </p:txBody>
+      </p:sp>
+      <p:sp>
+        <p:nvSpPr>
+          <p:cNvPr id="6" name="TextBox 5"/>
+          <p:cNvSpPr txBox="1"/>
+          <p:nvPr/>
+        </p:nvSpPr>
+        <p:spPr>
+          <a:xfrm>
+            <a:off x="685800" y="960120"/>
+            <a:ext cx="10972800" cy="320040"/>
+          </a:xfrm>
+          <a:prstGeom prst="rect">
+            <a:avLst/>
+          </a:prstGeom>
+          <a:noFill/>
+        </p:spPr>
+        <p:txBody>
+          <a:bodyPr wrap="square" lIns="45720" rIns="45720" tIns="18288" bIns="18288">
+            <a:spAutoFit/>
+          </a:bodyPr>
+          <a:lstStyle/>
+          <a:p>
+            <a:pPr algn="l"/>
+            <a:r>
+              <a:rPr sz="1200" b="0">
+                <a:solidFill>
+                  <a:srgbClr val="9AA3AF"/>
+                </a:solidFill>
+                <a:latin typeface="Segoe UI"/>
+              </a:rPr>
+              <a:t>From /run to a working pitch in two minutes</a:t>
+            </a:r>
+          </a:p>
+        </p:txBody>
+      </p:sp>
+      <p:pic>
+        <p:nvPicPr>
+          <p:cNvPr id="7" name="Picture 6" descr="01a-invoke.jpg"/>
+          <p:cNvPicPr>
+            <a:picLocks noChangeAspect="1"/>
+          </p:cNvPicPr>
+          <p:nvPr/>
+        </p:nvPicPr>
+        <p:blipFill>
+          <a:blip r:embed="rId2"/>
+          <a:stretch>
+            <a:fillRect/>
+          </a:stretch>
+        </p:blipFill>
+        <p:spPr>
+          <a:xfrm>
+            <a:off x="457200" y="2023025"/>
+            <a:ext cx="5577840" cy="2949108"/>
+          </a:xfrm>
+          <a:prstGeom prst="rect">
+            <a:avLst/>
+          </a:prstGeom>
+          <a:ln w="9525">
+            <a:solidFill>
+              <a:srgbClr val="34A87E"/>
+            </a:solidFill>
+          </a:ln>
+        </p:spPr>
+      </p:pic>
+      <p:pic>
+        <p:nvPicPr>
+          <p:cNvPr id="8" name="Picture 7" descr="01b-interrogator-pitch.jpg"/>
+          <p:cNvPicPr>
+            <a:picLocks noChangeAspect="1"/>
+          </p:cNvPicPr>
+          <p:nvPr/>
+        </p:nvPicPr>
+        <p:blipFill>
+          <a:blip r:embed="rId3"/>
+          <a:stretch>
+            <a:fillRect/>
+          </a:stretch>
+        </p:blipFill>
+        <p:spPr>
+          <a:xfrm>
+            <a:off x="6172200" y="2725263"/>
+            <a:ext cx="5577840" cy="1544632"/>
+          </a:xfrm>
+          <a:prstGeom prst="rect">
+            <a:avLst/>
+          </a:prstGeom>
+          <a:ln w="9525">
+            <a:solidFill>
+              <a:srgbClr val="34A87E"/>
+            </a:solidFill>
+          </a:ln>
+        </p:spPr>
+      </p:pic>
+      <p:sp>
+        <p:nvSpPr>
+          <p:cNvPr id="9" name="Rounded Rectangle 8"/>
+          <p:cNvSpPr/>
+          <p:nvPr/>
+        </p:nvSpPr>
+        <p:spPr>
+          <a:xfrm>
+            <a:off x="457200" y="5806440"/>
+            <a:ext cx="11247120" cy="502920"/>
+          </a:xfrm>
+          <a:prstGeom prst="roundRect">
+            <a:avLst/>
+          </a:prstGeom>
+          <a:solidFill>
+            <a:srgbClr val="181F2A"/>
+          </a:solidFill>
+          <a:ln w="9525">
+            <a:solidFill>
+              <a:srgbClr val="34A87E"/>
+            </a:solidFill>
+          </a:ln>
+          <a:effectLst/>
+        </p:spPr>
+        <p:style>
+          <a:lnRef idx="1">
+            <a:schemeClr val="accent1"/>
+          </a:lnRef>
+          <a:fillRef idx="3">
+            <a:schemeClr val="accent1"/>
+          </a:fillRef>
+          <a:effectRef idx="2">
+            <a:schemeClr val="accent1"/>
+          </a:effectRef>
+          <a:fontRef idx="minor">
+            <a:schemeClr val="lt1"/>
+          </a:fontRef>
+        </p:style>
+        <p:txBody>
+          <a:bodyPr rtlCol="0" anchor="ctr"/>
+          <a:lstStyle/>
+          <a:p>
+            <a:pPr algn="ctr"/>
+          </a:p>
+        </p:txBody>
+      </p:sp>
+      <p:sp>
+        <p:nvSpPr>
+          <p:cNvPr id="10" name="TextBox 9"/>
+          <p:cNvSpPr txBox="1"/>
+          <p:nvPr/>
+        </p:nvSpPr>
+        <p:spPr>
+          <a:xfrm>
+            <a:off x="685800" y="5897880"/>
+            <a:ext cx="10789920" cy="365760"/>
+          </a:xfrm>
+          <a:prstGeom prst="rect">
+            <a:avLst/>
+          </a:prstGeom>
+          <a:noFill/>
+        </p:spPr>
+        <p:txBody>
+          <a:bodyPr wrap="square" lIns="45720" rIns="45720" tIns="18288" bIns="18288">
+            <a:spAutoFit/>
+          </a:bodyPr>
+          <a:lstStyle/>
+          <a:p>
+            <a:pPr algn="l"/>
+            <a:r>
+              <a:rPr sz="1300" b="0">
+                <a:solidFill>
+                  <a:srgbClr val="E8ECF1"/>
+                </a:solidFill>
+                <a:latin typeface="Segoe UI"/>
+              </a:rPr>
+              <a:t>Left: /run skill confirmation.   Right: the interrogator's working pitch — webhooksig was born here.</a:t>
+            </a:r>
+          </a:p>
+        </p:txBody>
+      </p:sp>
+      <p:sp>
+        <p:nvSpPr>
+          <p:cNvPr id="11" name="TextBox 10"/>
+          <p:cNvSpPr txBox="1"/>
+          <p:nvPr/>
+        </p:nvSpPr>
+        <p:spPr>
+          <a:xfrm>
+            <a:off x="457200" y="6400800"/>
+            <a:ext cx="5486400" cy="274320"/>
+          </a:xfrm>
+          <a:prstGeom prst="rect">
+            <a:avLst/>
+          </a:prstGeom>
+          <a:noFill/>
+        </p:spPr>
+        <p:txBody>
+          <a:bodyPr wrap="square" lIns="45720" rIns="45720" tIns="18288" bIns="18288">
+            <a:spAutoFit/>
+          </a:bodyPr>
+          <a:lstStyle/>
+          <a:p>
+            <a:pPr algn="l"/>
+            <a:r>
+              <a:rPr sz="1000" b="0">
+                <a:solidFill>
+                  <a:srgbClr val="9AA3AF"/>
+                </a:solidFill>
+                <a:latin typeface="Segoe UI"/>
+              </a:rPr>
+              <a:t>EFF-IT  —  A Claude Code harness</a:t>
+            </a:r>
+          </a:p>
+        </p:txBody>
+      </p:sp>
+      <p:sp>
+        <p:nvSpPr>
+          <p:cNvPr id="12" name="TextBox 11"/>
+          <p:cNvSpPr txBox="1"/>
+          <p:nvPr/>
+        </p:nvSpPr>
+        <p:spPr>
+          <a:xfrm>
+            <a:off x="10515600" y="6400800"/>
+            <a:ext cx="1645920" cy="274320"/>
+          </a:xfrm>
+          <a:prstGeom prst="rect">
+            <a:avLst/>
+          </a:prstGeom>
+          <a:noFill/>
+        </p:spPr>
+        <p:txBody>
+          <a:bodyPr wrap="square" lIns="45720" rIns="45720" tIns="18288" bIns="18288">
+            <a:spAutoFit/>
+          </a:bodyPr>
+          <a:lstStyle/>
+          <a:p>
+            <a:pPr algn="r"/>
+            <a:r>
+              <a:rPr sz="1000" b="0">
+                <a:solidFill>
+                  <a:srgbClr val="9AA3AF"/>
+                </a:solidFill>
+                <a:latin typeface="Segoe UI"/>
+              </a:rPr>
+              <a:t>16 / 23</a:t>
+            </a:r>
+          </a:p>
+        </p:txBody>
+      </p:sp>
+    </p:spTree>
+  </p:cSld>
+  <p:clrMapOvr>
+    <a:masterClrMapping/>
+  </p:clrMapOvr>
+</p:sld>
+</file>
+
+<file path=ppt/slides/slide17.xml><?xml version="1.0" encoding="utf-8"?>
+<p:sld xmlns:a="http://schemas.openxmlformats.org/drawingml/2006/main" xmlns:p="http://schemas.openxmlformats.org/presentationml/2006/main" xmlns:r="http://schemas.openxmlformats.org/officeDocument/2006/relationships">
+  <p:cSld>
+    <p:spTree>
+      <p:nvGrpSpPr>
+        <p:cNvPr id="1" name=""/>
+        <p:cNvGrpSpPr/>
+        <p:nvPr/>
+      </p:nvGrpSpPr>
+      <p:grpSpPr/>
+      <p:sp>
+        <p:nvSpPr>
+          <p:cNvPr id="2" name="Rectangle 1"/>
+          <p:cNvSpPr/>
+          <p:nvPr/>
+        </p:nvSpPr>
+        <p:spPr>
+          <a:xfrm>
+            <a:off x="0" y="0"/>
+            <a:ext cx="12191695" cy="6858000"/>
+          </a:xfrm>
+          <a:prstGeom prst="rect">
+            <a:avLst/>
+          </a:prstGeom>
+          <a:solidFill>
+            <a:srgbClr val="0F141A"/>
+          </a:solidFill>
+          <a:ln>
+            <a:noFill/>
+          </a:ln>
+          <a:effectLst/>
+        </p:spPr>
+        <p:style>
+          <a:lnRef idx="1">
+            <a:schemeClr val="accent1"/>
+          </a:lnRef>
+          <a:fillRef idx="3">
+            <a:schemeClr val="accent1"/>
+          </a:fillRef>
+          <a:effectRef idx="2">
+            <a:schemeClr val="accent1"/>
+          </a:effectRef>
+          <a:fontRef idx="minor">
+            <a:schemeClr val="lt1"/>
+          </a:fontRef>
+        </p:style>
+        <p:txBody>
+          <a:bodyPr rtlCol="0" anchor="ctr"/>
+          <a:lstStyle/>
+          <a:p>
+            <a:pPr algn="ctr"/>
+          </a:p>
+        </p:txBody>
+      </p:sp>
+      <p:sp>
+        <p:nvSpPr>
+          <p:cNvPr id="3" name="Rectangle 2"/>
+          <p:cNvSpPr/>
+          <p:nvPr/>
+        </p:nvSpPr>
+        <p:spPr>
+          <a:xfrm>
+            <a:off x="457200" y="411480"/>
+            <a:ext cx="73152" cy="502920"/>
+          </a:xfrm>
+          <a:prstGeom prst="rect">
+            <a:avLst/>
+          </a:prstGeom>
+          <a:solidFill>
+            <a:srgbClr val="6EE7B7"/>
+          </a:solidFill>
+          <a:ln>
+            <a:noFill/>
+          </a:ln>
+          <a:effectLst/>
+        </p:spPr>
+        <p:style>
+          <a:lnRef idx="1">
+            <a:schemeClr val="accent1"/>
+          </a:lnRef>
+          <a:fillRef idx="3">
+            <a:schemeClr val="accent1"/>
+          </a:fillRef>
+          <a:effectRef idx="2">
+            <a:schemeClr val="accent1"/>
+          </a:effectRef>
+          <a:fontRef idx="minor">
+            <a:schemeClr val="lt1"/>
+          </a:fontRef>
+        </p:style>
+        <p:txBody>
+          <a:bodyPr rtlCol="0" anchor="ctr"/>
+          <a:lstStyle/>
+          <a:p>
+            <a:pPr algn="ctr"/>
+          </a:p>
+        </p:txBody>
+      </p:sp>
+      <p:sp>
+        <p:nvSpPr>
+          <p:cNvPr id="4" name="TextBox 3"/>
+          <p:cNvSpPr txBox="1"/>
+          <p:nvPr/>
+        </p:nvSpPr>
+        <p:spPr>
+          <a:xfrm>
+            <a:off x="685800" y="292608"/>
+            <a:ext cx="1828800" cy="365760"/>
+          </a:xfrm>
+          <a:prstGeom prst="rect">
+            <a:avLst/>
+          </a:prstGeom>
+          <a:noFill/>
+        </p:spPr>
+        <p:txBody>
+          <a:bodyPr wrap="square" lIns="45720" rIns="45720" tIns="18288" bIns="18288">
+            <a:spAutoFit/>
+          </a:bodyPr>
+          <a:lstStyle/>
+          <a:p>
+            <a:pPr algn="l"/>
+            <a:r>
+              <a:rPr sz="1100" b="1">
+                <a:solidFill>
+                  <a:srgbClr val="6EE7B7"/>
+                </a:solidFill>
+                <a:latin typeface="Segoe UI"/>
+              </a:rPr>
+              <a:t>APPENDIX · 2 / 8</a:t>
+            </a:r>
+          </a:p>
+        </p:txBody>
+      </p:sp>
+      <p:sp>
+        <p:nvSpPr>
+          <p:cNvPr id="5" name="TextBox 4"/>
+          <p:cNvSpPr txBox="1"/>
+          <p:nvPr/>
+        </p:nvSpPr>
+        <p:spPr>
+          <a:xfrm>
+            <a:off x="685800" y="594360"/>
+            <a:ext cx="10972800" cy="457200"/>
+          </a:xfrm>
+          <a:prstGeom prst="rect">
+            <a:avLst/>
+          </a:prstGeom>
+          <a:noFill/>
+        </p:spPr>
+        <p:txBody>
+          <a:bodyPr wrap="square" lIns="45720" rIns="45720" tIns="18288" bIns="18288">
+            <a:spAutoFit/>
+          </a:bodyPr>
+          <a:lstStyle/>
+          <a:p>
+            <a:pPr algn="l"/>
+            <a:r>
+              <a:rPr sz="2400" b="1">
+                <a:solidFill>
+                  <a:srgbClr val="E8ECF1"/>
+                </a:solidFill>
+                <a:latin typeface="Segoe UI"/>
+              </a:rPr>
+              <a:t>Step 2: SPEC.md emerges</a:t>
+            </a:r>
+          </a:p>
+        </p:txBody>
+      </p:sp>
+      <p:sp>
+        <p:nvSpPr>
+          <p:cNvPr id="6" name="TextBox 5"/>
+          <p:cNvSpPr txBox="1"/>
+          <p:nvPr/>
+        </p:nvSpPr>
+        <p:spPr>
+          <a:xfrm>
+            <a:off x="685800" y="960120"/>
+            <a:ext cx="10972800" cy="320040"/>
+          </a:xfrm>
+          <a:prstGeom prst="rect">
+            <a:avLst/>
+          </a:prstGeom>
+          <a:noFill/>
+        </p:spPr>
+        <p:txBody>
+          <a:bodyPr wrap="square" lIns="45720" rIns="45720" tIns="18288" bIns="18288">
+            <a:spAutoFit/>
+          </a:bodyPr>
+          <a:lstStyle/>
+          <a:p>
+            <a:pPr algn="l"/>
+            <a:r>
+              <a:rPr sz="1200" b="0">
+                <a:solidFill>
+                  <a:srgbClr val="9AA3AF"/>
+                </a:solidFill>
+                <a:latin typeface="Segoe UI"/>
+              </a:rPr>
+              <a:t>The contract karen audits against, hours from now</a:t>
+            </a:r>
+          </a:p>
+        </p:txBody>
+      </p:sp>
+      <p:pic>
+        <p:nvPicPr>
+          <p:cNvPr id="7" name="Picture 6" descr="02-spec.jpg"/>
+          <p:cNvPicPr>
+            <a:picLocks noChangeAspect="1"/>
+          </p:cNvPicPr>
+          <p:nvPr/>
+        </p:nvPicPr>
+        <p:blipFill>
+          <a:blip r:embed="rId2"/>
+          <a:stretch>
+            <a:fillRect/>
+          </a:stretch>
+        </p:blipFill>
+        <p:spPr>
+          <a:xfrm>
+            <a:off x="2567178" y="1325880"/>
+            <a:ext cx="7027164" cy="4343400"/>
+          </a:xfrm>
+          <a:prstGeom prst="rect">
+            <a:avLst/>
+          </a:prstGeom>
+          <a:ln w="9525">
+            <a:solidFill>
+              <a:srgbClr val="34A87E"/>
+            </a:solidFill>
+          </a:ln>
+        </p:spPr>
+      </p:pic>
+      <p:sp>
+        <p:nvSpPr>
+          <p:cNvPr id="8" name="Rounded Rectangle 7"/>
+          <p:cNvSpPr/>
+          <p:nvPr/>
+        </p:nvSpPr>
+        <p:spPr>
+          <a:xfrm>
+            <a:off x="457200" y="5806440"/>
+            <a:ext cx="11247120" cy="502920"/>
+          </a:xfrm>
+          <a:prstGeom prst="roundRect">
+            <a:avLst/>
+          </a:prstGeom>
+          <a:solidFill>
+            <a:srgbClr val="181F2A"/>
+          </a:solidFill>
+          <a:ln w="9525">
+            <a:solidFill>
+              <a:srgbClr val="34A87E"/>
+            </a:solidFill>
+          </a:ln>
+          <a:effectLst/>
+        </p:spPr>
+        <p:style>
+          <a:lnRef idx="1">
+            <a:schemeClr val="accent1"/>
+          </a:lnRef>
+          <a:fillRef idx="3">
+            <a:schemeClr val="accent1"/>
+          </a:fillRef>
+          <a:effectRef idx="2">
+            <a:schemeClr val="accent1"/>
+          </a:effectRef>
+          <a:fontRef idx="minor">
+            <a:schemeClr val="lt1"/>
+          </a:fontRef>
+        </p:style>
+        <p:txBody>
+          <a:bodyPr rtlCol="0" anchor="ctr"/>
+          <a:lstStyle/>
+          <a:p>
+            <a:pPr algn="ctr"/>
+          </a:p>
+        </p:txBody>
+      </p:sp>
+      <p:sp>
+        <p:nvSpPr>
+          <p:cNvPr id="9" name="TextBox 8"/>
+          <p:cNvSpPr txBox="1"/>
+          <p:nvPr/>
+        </p:nvSpPr>
+        <p:spPr>
+          <a:xfrm>
+            <a:off x="685800" y="5897880"/>
+            <a:ext cx="10789920" cy="365760"/>
+          </a:xfrm>
+          <a:prstGeom prst="rect">
+            <a:avLst/>
+          </a:prstGeom>
+          <a:noFill/>
+        </p:spPr>
+        <p:txBody>
+          <a:bodyPr wrap="square" lIns="45720" rIns="45720" tIns="18288" bIns="18288">
+            <a:spAutoFit/>
+          </a:bodyPr>
+          <a:lstStyle/>
+          <a:p>
+            <a:pPr algn="l"/>
+            <a:r>
+              <a:rPr sz="1300" b="0">
+                <a:solidFill>
+                  <a:srgbClr val="E8ECF1"/>
+                </a:solidFill>
+                <a:latin typeface="Segoe UI"/>
+              </a:rPr>
+              <a:t>Goals, non-goals, users, scope — drafted before a single source file is touched.</a:t>
+            </a:r>
+          </a:p>
+        </p:txBody>
+      </p:sp>
+      <p:sp>
+        <p:nvSpPr>
+          <p:cNvPr id="10" name="TextBox 9"/>
+          <p:cNvSpPr txBox="1"/>
+          <p:nvPr/>
+        </p:nvSpPr>
+        <p:spPr>
+          <a:xfrm>
+            <a:off x="457200" y="6400800"/>
+            <a:ext cx="5486400" cy="274320"/>
+          </a:xfrm>
+          <a:prstGeom prst="rect">
+            <a:avLst/>
+          </a:prstGeom>
+          <a:noFill/>
+        </p:spPr>
+        <p:txBody>
+          <a:bodyPr wrap="square" lIns="45720" rIns="45720" tIns="18288" bIns="18288">
+            <a:spAutoFit/>
+          </a:bodyPr>
+          <a:lstStyle/>
+          <a:p>
+            <a:pPr algn="l"/>
+            <a:r>
+              <a:rPr sz="1000" b="0">
+                <a:solidFill>
+                  <a:srgbClr val="9AA3AF"/>
+                </a:solidFill>
+                <a:latin typeface="Segoe UI"/>
+              </a:rPr>
+              <a:t>EFF-IT  —  A Claude Code harness</a:t>
+            </a:r>
+          </a:p>
+        </p:txBody>
+      </p:sp>
+      <p:sp>
+        <p:nvSpPr>
+          <p:cNvPr id="11" name="TextBox 10"/>
+          <p:cNvSpPr txBox="1"/>
+          <p:nvPr/>
+        </p:nvSpPr>
+        <p:spPr>
+          <a:xfrm>
+            <a:off x="10515600" y="6400800"/>
+            <a:ext cx="1645920" cy="274320"/>
+          </a:xfrm>
+          <a:prstGeom prst="rect">
+            <a:avLst/>
+          </a:prstGeom>
+          <a:noFill/>
+        </p:spPr>
+        <p:txBody>
+          <a:bodyPr wrap="square" lIns="45720" rIns="45720" tIns="18288" bIns="18288">
+            <a:spAutoFit/>
+          </a:bodyPr>
+          <a:lstStyle/>
+          <a:p>
+            <a:pPr algn="r"/>
+            <a:r>
+              <a:rPr sz="1000" b="0">
+                <a:solidFill>
+                  <a:srgbClr val="9AA3AF"/>
+                </a:solidFill>
+                <a:latin typeface="Segoe UI"/>
+              </a:rPr>
+              <a:t>17 / 23</a:t>
+            </a:r>
+          </a:p>
+        </p:txBody>
+      </p:sp>
+    </p:spTree>
+  </p:cSld>
+  <p:clrMapOvr>
+    <a:masterClrMapping/>
+  </p:clrMapOvr>
+</p:sld>
+</file>
+
+<file path=ppt/slides/slide18.xml><?xml version="1.0" encoding="utf-8"?>
+<p:sld xmlns:a="http://schemas.openxmlformats.org/drawingml/2006/main" xmlns:p="http://schemas.openxmlformats.org/presentationml/2006/main" xmlns:r="http://schemas.openxmlformats.org/officeDocument/2006/relationships">
+  <p:cSld>
+    <p:spTree>
+      <p:nvGrpSpPr>
+        <p:cNvPr id="1" name=""/>
+        <p:cNvGrpSpPr/>
+        <p:nvPr/>
+      </p:nvGrpSpPr>
+      <p:grpSpPr/>
+      <p:sp>
+        <p:nvSpPr>
+          <p:cNvPr id="2" name="Rectangle 1"/>
+          <p:cNvSpPr/>
+          <p:nvPr/>
+        </p:nvSpPr>
+        <p:spPr>
+          <a:xfrm>
+            <a:off x="0" y="0"/>
+            <a:ext cx="12191695" cy="6858000"/>
+          </a:xfrm>
+          <a:prstGeom prst="rect">
+            <a:avLst/>
+          </a:prstGeom>
+          <a:solidFill>
+            <a:srgbClr val="0F141A"/>
+          </a:solidFill>
+          <a:ln>
+            <a:noFill/>
+          </a:ln>
+          <a:effectLst/>
+        </p:spPr>
+        <p:style>
+          <a:lnRef idx="1">
+            <a:schemeClr val="accent1"/>
+          </a:lnRef>
+          <a:fillRef idx="3">
+            <a:schemeClr val="accent1"/>
+          </a:fillRef>
+          <a:effectRef idx="2">
+            <a:schemeClr val="accent1"/>
+          </a:effectRef>
+          <a:fontRef idx="minor">
+            <a:schemeClr val="lt1"/>
+          </a:fontRef>
+        </p:style>
+        <p:txBody>
+          <a:bodyPr rtlCol="0" anchor="ctr"/>
+          <a:lstStyle/>
+          <a:p>
+            <a:pPr algn="ctr"/>
+          </a:p>
+        </p:txBody>
+      </p:sp>
+      <p:sp>
+        <p:nvSpPr>
+          <p:cNvPr id="3" name="Rectangle 2"/>
+          <p:cNvSpPr/>
+          <p:nvPr/>
+        </p:nvSpPr>
+        <p:spPr>
+          <a:xfrm>
+            <a:off x="457200" y="411480"/>
+            <a:ext cx="73152" cy="502920"/>
+          </a:xfrm>
+          <a:prstGeom prst="rect">
+            <a:avLst/>
+          </a:prstGeom>
+          <a:solidFill>
+            <a:srgbClr val="6EE7B7"/>
+          </a:solidFill>
+          <a:ln>
+            <a:noFill/>
+          </a:ln>
+          <a:effectLst/>
+        </p:spPr>
+        <p:style>
+          <a:lnRef idx="1">
+            <a:schemeClr val="accent1"/>
+          </a:lnRef>
+          <a:fillRef idx="3">
+            <a:schemeClr val="accent1"/>
+          </a:fillRef>
+          <a:effectRef idx="2">
+            <a:schemeClr val="accent1"/>
+          </a:effectRef>
+          <a:fontRef idx="minor">
+            <a:schemeClr val="lt1"/>
+          </a:fontRef>
+        </p:style>
+        <p:txBody>
+          <a:bodyPr rtlCol="0" anchor="ctr"/>
+          <a:lstStyle/>
+          <a:p>
+            <a:pPr algn="ctr"/>
+          </a:p>
+        </p:txBody>
+      </p:sp>
+      <p:sp>
+        <p:nvSpPr>
+          <p:cNvPr id="4" name="TextBox 3"/>
+          <p:cNvSpPr txBox="1"/>
+          <p:nvPr/>
+        </p:nvSpPr>
+        <p:spPr>
+          <a:xfrm>
+            <a:off x="685800" y="292608"/>
+            <a:ext cx="1828800" cy="365760"/>
+          </a:xfrm>
+          <a:prstGeom prst="rect">
+            <a:avLst/>
+          </a:prstGeom>
+          <a:noFill/>
+        </p:spPr>
+        <p:txBody>
+          <a:bodyPr wrap="square" lIns="45720" rIns="45720" tIns="18288" bIns="18288">
+            <a:spAutoFit/>
+          </a:bodyPr>
+          <a:lstStyle/>
+          <a:p>
+            <a:pPr algn="l"/>
+            <a:r>
+              <a:rPr sz="1100" b="1">
+                <a:solidFill>
+                  <a:srgbClr val="6EE7B7"/>
+                </a:solidFill>
+                <a:latin typeface="Segoe UI"/>
+              </a:rPr>
+              <a:t>APPENDIX · 3 / 8</a:t>
+            </a:r>
+          </a:p>
+        </p:txBody>
+      </p:sp>
+      <p:sp>
+        <p:nvSpPr>
+          <p:cNvPr id="5" name="TextBox 4"/>
+          <p:cNvSpPr txBox="1"/>
+          <p:nvPr/>
+        </p:nvSpPr>
+        <p:spPr>
+          <a:xfrm>
+            <a:off x="685800" y="594360"/>
+            <a:ext cx="10972800" cy="457200"/>
+          </a:xfrm>
+          <a:prstGeom prst="rect">
+            <a:avLst/>
+          </a:prstGeom>
+          <a:noFill/>
+        </p:spPr>
+        <p:txBody>
+          <a:bodyPr wrap="square" lIns="45720" rIns="45720" tIns="18288" bIns="18288">
+            <a:spAutoFit/>
+          </a:bodyPr>
+          <a:lstStyle/>
+          <a:p>
+            <a:pPr algn="l"/>
+            <a:r>
+              <a:rPr sz="2400" b="1">
+                <a:solidFill>
+                  <a:srgbClr val="E8ECF1"/>
+                </a:solidFill>
+                <a:latin typeface="Segoe UI"/>
+              </a:rPr>
+              <a:t>Step 3: Security concerns, merged per app_type</a:t>
+            </a:r>
+          </a:p>
+        </p:txBody>
+      </p:sp>
+      <p:sp>
+        <p:nvSpPr>
+          <p:cNvPr id="6" name="TextBox 5"/>
+          <p:cNvSpPr txBox="1"/>
+          <p:nvPr/>
+        </p:nvSpPr>
+        <p:spPr>
+          <a:xfrm>
+            <a:off x="685800" y="960120"/>
+            <a:ext cx="10972800" cy="320040"/>
+          </a:xfrm>
+          <a:prstGeom prst="rect">
+            <a:avLst/>
+          </a:prstGeom>
+          <a:noFill/>
+        </p:spPr>
+        <p:txBody>
+          <a:bodyPr wrap="square" lIns="45720" rIns="45720" tIns="18288" bIns="18288">
+            <a:spAutoFit/>
+          </a:bodyPr>
+          <a:lstStyle/>
+          <a:p>
+            <a:pPr algn="l"/>
+            <a:r>
+              <a:rPr sz="1200" b="0">
+                <a:solidFill>
+                  <a:srgbClr val="9AA3AF"/>
+                </a:solidFill>
+                <a:latin typeface="Segoe UI"/>
+              </a:rPr>
+              <a:t>The threat-model story from slide 9 — in production form</a:t>
+            </a:r>
+          </a:p>
+        </p:txBody>
+      </p:sp>
+      <p:pic>
+        <p:nvPicPr>
+          <p:cNvPr id="7" name="Picture 6" descr="03a-security-concerns-1.jpg"/>
+          <p:cNvPicPr>
+            <a:picLocks noChangeAspect="1"/>
+          </p:cNvPicPr>
+          <p:nvPr/>
+        </p:nvPicPr>
+        <p:blipFill>
+          <a:blip r:embed="rId2"/>
+          <a:stretch>
+            <a:fillRect/>
+          </a:stretch>
+        </p:blipFill>
+        <p:spPr>
+          <a:xfrm>
+            <a:off x="457200" y="2337499"/>
+            <a:ext cx="5577840" cy="2320160"/>
+          </a:xfrm>
+          <a:prstGeom prst="rect">
+            <a:avLst/>
+          </a:prstGeom>
+          <a:ln w="9525">
+            <a:solidFill>
+              <a:srgbClr val="34A87E"/>
+            </a:solidFill>
+          </a:ln>
+        </p:spPr>
+      </p:pic>
+      <p:pic>
+        <p:nvPicPr>
+          <p:cNvPr id="8" name="Picture 7" descr="03b-security-concerns-2.jpg"/>
+          <p:cNvPicPr>
+            <a:picLocks noChangeAspect="1"/>
+          </p:cNvPicPr>
+          <p:nvPr/>
+        </p:nvPicPr>
+        <p:blipFill>
+          <a:blip r:embed="rId3"/>
+          <a:stretch>
+            <a:fillRect/>
+          </a:stretch>
+        </p:blipFill>
+        <p:spPr>
+          <a:xfrm>
+            <a:off x="6172200" y="2166452"/>
+            <a:ext cx="5577840" cy="2662255"/>
+          </a:xfrm>
+          <a:prstGeom prst="rect">
+            <a:avLst/>
+          </a:prstGeom>
+          <a:ln w="9525">
+            <a:solidFill>
+              <a:srgbClr val="34A87E"/>
+            </a:solidFill>
+          </a:ln>
+        </p:spPr>
+      </p:pic>
+      <p:sp>
+        <p:nvSpPr>
+          <p:cNvPr id="9" name="Rounded Rectangle 8"/>
+          <p:cNvSpPr/>
+          <p:nvPr/>
+        </p:nvSpPr>
+        <p:spPr>
+          <a:xfrm>
+            <a:off x="457200" y="5806440"/>
+            <a:ext cx="11247120" cy="502920"/>
+          </a:xfrm>
+          <a:prstGeom prst="roundRect">
+            <a:avLst/>
+          </a:prstGeom>
+          <a:solidFill>
+            <a:srgbClr val="181F2A"/>
+          </a:solidFill>
+          <a:ln w="9525">
+            <a:solidFill>
+              <a:srgbClr val="34A87E"/>
+            </a:solidFill>
+          </a:ln>
+          <a:effectLst/>
+        </p:spPr>
+        <p:style>
+          <a:lnRef idx="1">
+            <a:schemeClr val="accent1"/>
+          </a:lnRef>
+          <a:fillRef idx="3">
+            <a:schemeClr val="accent1"/>
+          </a:fillRef>
+          <a:effectRef idx="2">
+            <a:schemeClr val="accent1"/>
+          </a:effectRef>
+          <a:fontRef idx="minor">
+            <a:schemeClr val="lt1"/>
+          </a:fontRef>
+        </p:style>
+        <p:txBody>
+          <a:bodyPr rtlCol="0" anchor="ctr"/>
+          <a:lstStyle/>
+          <a:p>
+            <a:pPr algn="ctr"/>
+          </a:p>
+        </p:txBody>
+      </p:sp>
+      <p:sp>
+        <p:nvSpPr>
+          <p:cNvPr id="10" name="TextBox 9"/>
+          <p:cNvSpPr txBox="1"/>
+          <p:nvPr/>
+        </p:nvSpPr>
+        <p:spPr>
+          <a:xfrm>
+            <a:off x="685800" y="5897880"/>
+            <a:ext cx="10789920" cy="365760"/>
+          </a:xfrm>
+          <a:prstGeom prst="rect">
+            <a:avLst/>
+          </a:prstGeom>
+          <a:noFill/>
+        </p:spPr>
+        <p:txBody>
+          <a:bodyPr wrap="square" lIns="45720" rIns="45720" tIns="18288" bIns="18288">
+            <a:spAutoFit/>
+          </a:bodyPr>
+          <a:lstStyle/>
+          <a:p>
+            <a:pPr algn="l"/>
+            <a:r>
+              <a:rPr sz="1300" b="0">
+                <a:solidFill>
+                  <a:srgbClr val="E8ECF1"/>
+                </a:solidFill>
+                <a:latin typeface="Segoe UI"/>
+              </a:rPr>
+              <a:t>concern-resolver reads security/concerns/*.md and unions per declared app_type → SECURITY_CONCERNS.md.</a:t>
+            </a:r>
+          </a:p>
+        </p:txBody>
+      </p:sp>
+      <p:sp>
+        <p:nvSpPr>
+          <p:cNvPr id="11" name="TextBox 10"/>
+          <p:cNvSpPr txBox="1"/>
+          <p:nvPr/>
+        </p:nvSpPr>
+        <p:spPr>
+          <a:xfrm>
+            <a:off x="457200" y="6400800"/>
+            <a:ext cx="5486400" cy="274320"/>
+          </a:xfrm>
+          <a:prstGeom prst="rect">
+            <a:avLst/>
+          </a:prstGeom>
+          <a:noFill/>
+        </p:spPr>
+        <p:txBody>
+          <a:bodyPr wrap="square" lIns="45720" rIns="45720" tIns="18288" bIns="18288">
+            <a:spAutoFit/>
+          </a:bodyPr>
+          <a:lstStyle/>
+          <a:p>
+            <a:pPr algn="l"/>
+            <a:r>
+              <a:rPr sz="1000" b="0">
+                <a:solidFill>
+                  <a:srgbClr val="9AA3AF"/>
+                </a:solidFill>
+                <a:latin typeface="Segoe UI"/>
+              </a:rPr>
+              <a:t>EFF-IT  —  A Claude Code harness</a:t>
+            </a:r>
+          </a:p>
+        </p:txBody>
+      </p:sp>
+      <p:sp>
+        <p:nvSpPr>
+          <p:cNvPr id="12" name="TextBox 11"/>
+          <p:cNvSpPr txBox="1"/>
+          <p:nvPr/>
+        </p:nvSpPr>
+        <p:spPr>
+          <a:xfrm>
+            <a:off x="10515600" y="6400800"/>
+            <a:ext cx="1645920" cy="274320"/>
+          </a:xfrm>
+          <a:prstGeom prst="rect">
+            <a:avLst/>
+          </a:prstGeom>
+          <a:noFill/>
+        </p:spPr>
+        <p:txBody>
+          <a:bodyPr wrap="square" lIns="45720" rIns="45720" tIns="18288" bIns="18288">
+            <a:spAutoFit/>
+          </a:bodyPr>
+          <a:lstStyle/>
+          <a:p>
+            <a:pPr algn="r"/>
+            <a:r>
+              <a:rPr sz="1000" b="0">
+                <a:solidFill>
+                  <a:srgbClr val="9AA3AF"/>
+                </a:solidFill>
+                <a:latin typeface="Segoe UI"/>
+              </a:rPr>
+              <a:t>18 / 23</a:t>
+            </a:r>
+          </a:p>
+        </p:txBody>
+      </p:sp>
+    </p:spTree>
+  </p:cSld>
+  <p:clrMapOvr>
+    <a:masterClrMapping/>
+  </p:clrMapOvr>
+</p:sld>
+</file>
+
+<file path=ppt/slides/slide19.xml><?xml version="1.0" encoding="utf-8"?>
+<p:sld xmlns:a="http://schemas.openxmlformats.org/drawingml/2006/main" xmlns:p="http://schemas.openxmlformats.org/presentationml/2006/main" xmlns:r="http://schemas.openxmlformats.org/officeDocument/2006/relationships">
+  <p:cSld>
+    <p:spTree>
+      <p:nvGrpSpPr>
+        <p:cNvPr id="1" name=""/>
+        <p:cNvGrpSpPr/>
+        <p:nvPr/>
+      </p:nvGrpSpPr>
+      <p:grpSpPr/>
+      <p:sp>
+        <p:nvSpPr>
+          <p:cNvPr id="2" name="Rectangle 1"/>
+          <p:cNvSpPr/>
+          <p:nvPr/>
+        </p:nvSpPr>
+        <p:spPr>
+          <a:xfrm>
+            <a:off x="0" y="0"/>
+            <a:ext cx="12191695" cy="6858000"/>
+          </a:xfrm>
+          <a:prstGeom prst="rect">
+            <a:avLst/>
+          </a:prstGeom>
+          <a:solidFill>
+            <a:srgbClr val="0F141A"/>
+          </a:solidFill>
+          <a:ln>
+            <a:noFill/>
+          </a:ln>
+          <a:effectLst/>
+        </p:spPr>
+        <p:style>
+          <a:lnRef idx="1">
+            <a:schemeClr val="accent1"/>
+          </a:lnRef>
+          <a:fillRef idx="3">
+            <a:schemeClr val="accent1"/>
+          </a:fillRef>
+          <a:effectRef idx="2">
+            <a:schemeClr val="accent1"/>
+          </a:effectRef>
+          <a:fontRef idx="minor">
+            <a:schemeClr val="lt1"/>
+          </a:fontRef>
+        </p:style>
+        <p:txBody>
+          <a:bodyPr rtlCol="0" anchor="ctr"/>
+          <a:lstStyle/>
+          <a:p>
+            <a:pPr algn="ctr"/>
+          </a:p>
+        </p:txBody>
+      </p:sp>
+      <p:sp>
+        <p:nvSpPr>
+          <p:cNvPr id="3" name="Rectangle 2"/>
+          <p:cNvSpPr/>
+          <p:nvPr/>
+        </p:nvSpPr>
+        <p:spPr>
+          <a:xfrm>
+            <a:off x="457200" y="411480"/>
+            <a:ext cx="73152" cy="502920"/>
+          </a:xfrm>
+          <a:prstGeom prst="rect">
+            <a:avLst/>
+          </a:prstGeom>
+          <a:solidFill>
+            <a:srgbClr val="6EE7B7"/>
+          </a:solidFill>
+          <a:ln>
+            <a:noFill/>
+          </a:ln>
+          <a:effectLst/>
+        </p:spPr>
+        <p:style>
+          <a:lnRef idx="1">
+            <a:schemeClr val="accent1"/>
+          </a:lnRef>
+          <a:fillRef idx="3">
+            <a:schemeClr val="accent1"/>
+          </a:fillRef>
+          <a:effectRef idx="2">
+            <a:schemeClr val="accent1"/>
+          </a:effectRef>
+          <a:fontRef idx="minor">
+            <a:schemeClr val="lt1"/>
+          </a:fontRef>
+        </p:style>
+        <p:txBody>
+          <a:bodyPr rtlCol="0" anchor="ctr"/>
+          <a:lstStyle/>
+          <a:p>
+            <a:pPr algn="ctr"/>
+          </a:p>
+        </p:txBody>
+      </p:sp>
+      <p:sp>
+        <p:nvSpPr>
+          <p:cNvPr id="4" name="TextBox 3"/>
+          <p:cNvSpPr txBox="1"/>
+          <p:nvPr/>
+        </p:nvSpPr>
+        <p:spPr>
+          <a:xfrm>
+            <a:off x="685800" y="292608"/>
+            <a:ext cx="1828800" cy="365760"/>
+          </a:xfrm>
+          <a:prstGeom prst="rect">
+            <a:avLst/>
+          </a:prstGeom>
+          <a:noFill/>
+        </p:spPr>
+        <p:txBody>
+          <a:bodyPr wrap="square" lIns="45720" rIns="45720" tIns="18288" bIns="18288">
+            <a:spAutoFit/>
+          </a:bodyPr>
+          <a:lstStyle/>
+          <a:p>
+            <a:pPr algn="l"/>
+            <a:r>
+              <a:rPr sz="1100" b="1">
+                <a:solidFill>
+                  <a:srgbClr val="6EE7B7"/>
+                </a:solidFill>
+                <a:latin typeface="Segoe UI"/>
+              </a:rPr>
+              <a:t>APPENDIX · 4 / 8</a:t>
+            </a:r>
+          </a:p>
+        </p:txBody>
+      </p:sp>
+      <p:sp>
+        <p:nvSpPr>
+          <p:cNvPr id="5" name="TextBox 4"/>
+          <p:cNvSpPr txBox="1"/>
+          <p:nvPr/>
+        </p:nvSpPr>
+        <p:spPr>
+          <a:xfrm>
+            <a:off x="685800" y="594360"/>
+            <a:ext cx="10972800" cy="457200"/>
+          </a:xfrm>
+          <a:prstGeom prst="rect">
+            <a:avLst/>
+          </a:prstGeom>
+          <a:noFill/>
+        </p:spPr>
+        <p:txBody>
+          <a:bodyPr wrap="square" lIns="45720" rIns="45720" tIns="18288" bIns="18288">
+            <a:spAutoFit/>
+          </a:bodyPr>
+          <a:lstStyle/>
+          <a:p>
+            <a:pPr algn="l"/>
+            <a:r>
+              <a:rPr sz="2400" b="1">
+                <a:solidFill>
+                  <a:srgbClr val="E8ECF1"/>
+                </a:solidFill>
+                <a:latin typeface="Segoe UI"/>
+              </a:rPr>
+              <a:t>Step 4: ARCHITECTURE.md (plan-before-code)</a:t>
+            </a:r>
+          </a:p>
+        </p:txBody>
+      </p:sp>
+      <p:sp>
+        <p:nvSpPr>
+          <p:cNvPr id="6" name="TextBox 5"/>
+          <p:cNvSpPr txBox="1"/>
+          <p:nvPr/>
+        </p:nvSpPr>
+        <p:spPr>
+          <a:xfrm>
+            <a:off x="685800" y="960120"/>
+            <a:ext cx="10972800" cy="320040"/>
+          </a:xfrm>
+          <a:prstGeom prst="rect">
+            <a:avLst/>
+          </a:prstGeom>
+          <a:noFill/>
+        </p:spPr>
+        <p:txBody>
+          <a:bodyPr wrap="square" lIns="45720" rIns="45720" tIns="18288" bIns="18288">
+            <a:spAutoFit/>
+          </a:bodyPr>
+          <a:lstStyle/>
+          <a:p>
+            <a:pPr algn="l"/>
+            <a:r>
+              <a:rPr sz="1200" b="0">
+                <a:solidFill>
+                  <a:srgbClr val="9AA3AF"/>
+                </a:solidFill>
+                <a:latin typeface="Segoe UI"/>
+              </a:rPr>
+              <a:t>Trust boundary + HMAC call path, written before any source file</a:t>
+            </a:r>
+          </a:p>
+        </p:txBody>
+      </p:sp>
+      <p:pic>
+        <p:nvPicPr>
+          <p:cNvPr id="7" name="Picture 6" descr="04a-arch-system-context.jpg"/>
+          <p:cNvPicPr>
+            <a:picLocks noChangeAspect="1"/>
+          </p:cNvPicPr>
+          <p:nvPr/>
+        </p:nvPicPr>
+        <p:blipFill>
+          <a:blip r:embed="rId2"/>
+          <a:stretch>
+            <a:fillRect/>
+          </a:stretch>
+        </p:blipFill>
+        <p:spPr>
+          <a:xfrm>
+            <a:off x="630568" y="1325880"/>
+            <a:ext cx="5231102" cy="4343400"/>
+          </a:xfrm>
+          <a:prstGeom prst="rect">
+            <a:avLst/>
+          </a:prstGeom>
+          <a:ln w="9525">
+            <a:solidFill>
+              <a:srgbClr val="34A87E"/>
+            </a:solidFill>
+          </a:ln>
+        </p:spPr>
+      </p:pic>
+      <p:pic>
+        <p:nvPicPr>
+          <p:cNvPr id="8" name="Picture 7" descr="04b-arch-data-flow.jpg"/>
+          <p:cNvPicPr>
+            <a:picLocks noChangeAspect="1"/>
+          </p:cNvPicPr>
+          <p:nvPr/>
+        </p:nvPicPr>
+        <p:blipFill>
+          <a:blip r:embed="rId3"/>
+          <a:stretch>
+            <a:fillRect/>
+          </a:stretch>
+        </p:blipFill>
+        <p:spPr>
+          <a:xfrm>
+            <a:off x="6172200" y="1465753"/>
+            <a:ext cx="5577840" cy="4063653"/>
+          </a:xfrm>
+          <a:prstGeom prst="rect">
+            <a:avLst/>
+          </a:prstGeom>
+          <a:ln w="9525">
+            <a:solidFill>
+              <a:srgbClr val="34A87E"/>
+            </a:solidFill>
+          </a:ln>
+        </p:spPr>
+      </p:pic>
+      <p:sp>
+        <p:nvSpPr>
+          <p:cNvPr id="9" name="Rounded Rectangle 8"/>
+          <p:cNvSpPr/>
+          <p:nvPr/>
+        </p:nvSpPr>
+        <p:spPr>
+          <a:xfrm>
+            <a:off x="457200" y="5806440"/>
+            <a:ext cx="11247120" cy="502920"/>
+          </a:xfrm>
+          <a:prstGeom prst="roundRect">
+            <a:avLst/>
+          </a:prstGeom>
+          <a:solidFill>
+            <a:srgbClr val="181F2A"/>
+          </a:solidFill>
+          <a:ln w="9525">
+            <a:solidFill>
+              <a:srgbClr val="34A87E"/>
+            </a:solidFill>
+          </a:ln>
+          <a:effectLst/>
+        </p:spPr>
+        <p:style>
+          <a:lnRef idx="1">
+            <a:schemeClr val="accent1"/>
+          </a:lnRef>
+          <a:fillRef idx="3">
+            <a:schemeClr val="accent1"/>
+          </a:fillRef>
+          <a:effectRef idx="2">
+            <a:schemeClr val="accent1"/>
+          </a:effectRef>
+          <a:fontRef idx="minor">
+            <a:schemeClr val="lt1"/>
+          </a:fontRef>
+        </p:style>
+        <p:txBody>
+          <a:bodyPr rtlCol="0" anchor="ctr"/>
+          <a:lstStyle/>
+          <a:p>
+            <a:pPr algn="ctr"/>
+          </a:p>
+        </p:txBody>
+      </p:sp>
+      <p:sp>
+        <p:nvSpPr>
+          <p:cNvPr id="10" name="TextBox 9"/>
+          <p:cNvSpPr txBox="1"/>
+          <p:nvPr/>
+        </p:nvSpPr>
+        <p:spPr>
+          <a:xfrm>
+            <a:off x="685800" y="5897880"/>
+            <a:ext cx="10789920" cy="365760"/>
+          </a:xfrm>
+          <a:prstGeom prst="rect">
+            <a:avLst/>
+          </a:prstGeom>
+          <a:noFill/>
+        </p:spPr>
+        <p:txBody>
+          <a:bodyPr wrap="square" lIns="45720" rIns="45720" tIns="18288" bIns="18288">
+            <a:spAutoFit/>
+          </a:bodyPr>
+          <a:lstStyle/>
+          <a:p>
+            <a:pPr algn="l"/>
+            <a:r>
+              <a:rPr sz="1300" b="0">
+                <a:solidFill>
+                  <a:srgbClr val="E8ECF1"/>
+                </a:solidFill>
+                <a:latin typeface="Segoe UI"/>
+              </a:rPr>
+              <a:t>Left: system context with trust boundary.   Right: HMAC verify pseudocode — the algorithm settled before the code.</a:t>
+            </a:r>
+          </a:p>
+        </p:txBody>
+      </p:sp>
+      <p:sp>
+        <p:nvSpPr>
+          <p:cNvPr id="11" name="TextBox 10"/>
+          <p:cNvSpPr txBox="1"/>
+          <p:nvPr/>
+        </p:nvSpPr>
+        <p:spPr>
+          <a:xfrm>
+            <a:off x="457200" y="6400800"/>
+            <a:ext cx="5486400" cy="274320"/>
+          </a:xfrm>
+          <a:prstGeom prst="rect">
+            <a:avLst/>
+          </a:prstGeom>
+          <a:noFill/>
+        </p:spPr>
+        <p:txBody>
+          <a:bodyPr wrap="square" lIns="45720" rIns="45720" tIns="18288" bIns="18288">
+            <a:spAutoFit/>
+          </a:bodyPr>
+          <a:lstStyle/>
+          <a:p>
+            <a:pPr algn="l"/>
+            <a:r>
+              <a:rPr sz="1000" b="0">
+                <a:solidFill>
+                  <a:srgbClr val="9AA3AF"/>
+                </a:solidFill>
+                <a:latin typeface="Segoe UI"/>
+              </a:rPr>
+              <a:t>EFF-IT  —  A Claude Code harness</a:t>
+            </a:r>
+          </a:p>
+        </p:txBody>
+      </p:sp>
+      <p:sp>
+        <p:nvSpPr>
+          <p:cNvPr id="12" name="TextBox 11"/>
+          <p:cNvSpPr txBox="1"/>
+          <p:nvPr/>
+        </p:nvSpPr>
+        <p:spPr>
+          <a:xfrm>
+            <a:off x="10515600" y="6400800"/>
+            <a:ext cx="1645920" cy="274320"/>
+          </a:xfrm>
+          <a:prstGeom prst="rect">
+            <a:avLst/>
+          </a:prstGeom>
+          <a:noFill/>
+        </p:spPr>
+        <p:txBody>
+          <a:bodyPr wrap="square" lIns="45720" rIns="45720" tIns="18288" bIns="18288">
+            <a:spAutoFit/>
+          </a:bodyPr>
+          <a:lstStyle/>
+          <a:p>
+            <a:pPr algn="r"/>
+            <a:r>
+              <a:rPr sz="1000" b="0">
+                <a:solidFill>
+                  <a:srgbClr val="9AA3AF"/>
+                </a:solidFill>
+                <a:latin typeface="Segoe UI"/>
+              </a:rPr>
+              <a:t>19 / 23</a:t>
             </a:r>
           </a:p>
         </p:txBody>
@@ -9779,7 +13017,1629 @@
                 </a:solidFill>
                 <a:latin typeface="Segoe UI"/>
               </a:rPr>
-              <a:t>2 / 14</a:t>
+              <a:t>2 / 23</a:t>
+            </a:r>
+          </a:p>
+        </p:txBody>
+      </p:sp>
+    </p:spTree>
+  </p:cSld>
+  <p:clrMapOvr>
+    <a:masterClrMapping/>
+  </p:clrMapOvr>
+</p:sld>
+</file>
+
+<file path=ppt/slides/slide20.xml><?xml version="1.0" encoding="utf-8"?>
+<p:sld xmlns:a="http://schemas.openxmlformats.org/drawingml/2006/main" xmlns:p="http://schemas.openxmlformats.org/presentationml/2006/main" xmlns:r="http://schemas.openxmlformats.org/officeDocument/2006/relationships">
+  <p:cSld>
+    <p:spTree>
+      <p:nvGrpSpPr>
+        <p:cNvPr id="1" name=""/>
+        <p:cNvGrpSpPr/>
+        <p:nvPr/>
+      </p:nvGrpSpPr>
+      <p:grpSpPr/>
+      <p:sp>
+        <p:nvSpPr>
+          <p:cNvPr id="2" name="Rectangle 1"/>
+          <p:cNvSpPr/>
+          <p:nvPr/>
+        </p:nvSpPr>
+        <p:spPr>
+          <a:xfrm>
+            <a:off x="0" y="0"/>
+            <a:ext cx="12191695" cy="6858000"/>
+          </a:xfrm>
+          <a:prstGeom prst="rect">
+            <a:avLst/>
+          </a:prstGeom>
+          <a:solidFill>
+            <a:srgbClr val="0F141A"/>
+          </a:solidFill>
+          <a:ln>
+            <a:noFill/>
+          </a:ln>
+          <a:effectLst/>
+        </p:spPr>
+        <p:style>
+          <a:lnRef idx="1">
+            <a:schemeClr val="accent1"/>
+          </a:lnRef>
+          <a:fillRef idx="3">
+            <a:schemeClr val="accent1"/>
+          </a:fillRef>
+          <a:effectRef idx="2">
+            <a:schemeClr val="accent1"/>
+          </a:effectRef>
+          <a:fontRef idx="minor">
+            <a:schemeClr val="lt1"/>
+          </a:fontRef>
+        </p:style>
+        <p:txBody>
+          <a:bodyPr rtlCol="0" anchor="ctr"/>
+          <a:lstStyle/>
+          <a:p>
+            <a:pPr algn="ctr"/>
+          </a:p>
+        </p:txBody>
+      </p:sp>
+      <p:sp>
+        <p:nvSpPr>
+          <p:cNvPr id="3" name="Rectangle 2"/>
+          <p:cNvSpPr/>
+          <p:nvPr/>
+        </p:nvSpPr>
+        <p:spPr>
+          <a:xfrm>
+            <a:off x="457200" y="411480"/>
+            <a:ext cx="73152" cy="502920"/>
+          </a:xfrm>
+          <a:prstGeom prst="rect">
+            <a:avLst/>
+          </a:prstGeom>
+          <a:solidFill>
+            <a:srgbClr val="6EE7B7"/>
+          </a:solidFill>
+          <a:ln>
+            <a:noFill/>
+          </a:ln>
+          <a:effectLst/>
+        </p:spPr>
+        <p:style>
+          <a:lnRef idx="1">
+            <a:schemeClr val="accent1"/>
+          </a:lnRef>
+          <a:fillRef idx="3">
+            <a:schemeClr val="accent1"/>
+          </a:fillRef>
+          <a:effectRef idx="2">
+            <a:schemeClr val="accent1"/>
+          </a:effectRef>
+          <a:fontRef idx="minor">
+            <a:schemeClr val="lt1"/>
+          </a:fontRef>
+        </p:style>
+        <p:txBody>
+          <a:bodyPr rtlCol="0" anchor="ctr"/>
+          <a:lstStyle/>
+          <a:p>
+            <a:pPr algn="ctr"/>
+          </a:p>
+        </p:txBody>
+      </p:sp>
+      <p:sp>
+        <p:nvSpPr>
+          <p:cNvPr id="4" name="TextBox 3"/>
+          <p:cNvSpPr txBox="1"/>
+          <p:nvPr/>
+        </p:nvSpPr>
+        <p:spPr>
+          <a:xfrm>
+            <a:off x="685800" y="292608"/>
+            <a:ext cx="1828800" cy="365760"/>
+          </a:xfrm>
+          <a:prstGeom prst="rect">
+            <a:avLst/>
+          </a:prstGeom>
+          <a:noFill/>
+        </p:spPr>
+        <p:txBody>
+          <a:bodyPr wrap="square" lIns="45720" rIns="45720" tIns="18288" bIns="18288">
+            <a:spAutoFit/>
+          </a:bodyPr>
+          <a:lstStyle/>
+          <a:p>
+            <a:pPr algn="l"/>
+            <a:r>
+              <a:rPr sz="1100" b="1">
+                <a:solidFill>
+                  <a:srgbClr val="6EE7B7"/>
+                </a:solidFill>
+                <a:latin typeface="Segoe UI"/>
+              </a:rPr>
+              <a:t>APPENDIX · 5 / 8</a:t>
+            </a:r>
+          </a:p>
+        </p:txBody>
+      </p:sp>
+      <p:sp>
+        <p:nvSpPr>
+          <p:cNvPr id="5" name="TextBox 4"/>
+          <p:cNvSpPr txBox="1"/>
+          <p:nvPr/>
+        </p:nvSpPr>
+        <p:spPr>
+          <a:xfrm>
+            <a:off x="685800" y="594360"/>
+            <a:ext cx="10972800" cy="457200"/>
+          </a:xfrm>
+          <a:prstGeom prst="rect">
+            <a:avLst/>
+          </a:prstGeom>
+          <a:noFill/>
+        </p:spPr>
+        <p:txBody>
+          <a:bodyPr wrap="square" lIns="45720" rIns="45720" tIns="18288" bIns="18288">
+            <a:spAutoFit/>
+          </a:bodyPr>
+          <a:lstStyle/>
+          <a:p>
+            <a:pPr algn="l"/>
+            <a:r>
+              <a:rPr sz="2400" b="1">
+                <a:solidFill>
+                  <a:srgbClr val="E8ECF1"/>
+                </a:solidFill>
+                <a:latin typeface="Segoe UI"/>
+              </a:rPr>
+              <a:t>Step 5: Parallel coders + advisor escalation</a:t>
+            </a:r>
+          </a:p>
+        </p:txBody>
+      </p:sp>
+      <p:sp>
+        <p:nvSpPr>
+          <p:cNvPr id="6" name="TextBox 5"/>
+          <p:cNvSpPr txBox="1"/>
+          <p:nvPr/>
+        </p:nvSpPr>
+        <p:spPr>
+          <a:xfrm>
+            <a:off x="685800" y="960120"/>
+            <a:ext cx="10972800" cy="320040"/>
+          </a:xfrm>
+          <a:prstGeom prst="rect">
+            <a:avLst/>
+          </a:prstGeom>
+          <a:noFill/>
+        </p:spPr>
+        <p:txBody>
+          <a:bodyPr wrap="square" lIns="45720" rIns="45720" tIns="18288" bIns="18288">
+            <a:spAutoFit/>
+          </a:bodyPr>
+          <a:lstStyle/>
+          <a:p>
+            <a:pPr algn="l"/>
+            <a:r>
+              <a:rPr sz="1200" b="0">
+                <a:solidFill>
+                  <a:srgbClr val="9AA3AF"/>
+                </a:solidFill>
+                <a:latin typeface="Segoe UI"/>
+              </a:rPr>
+              <a:t>Four coders concurrent. One hits an ambiguous edge — calls the advisor.</a:t>
+            </a:r>
+          </a:p>
+        </p:txBody>
+      </p:sp>
+      <p:pic>
+        <p:nvPicPr>
+          <p:cNvPr id="7" name="Picture 6" descr="05a-parallel-coders.jpg"/>
+          <p:cNvPicPr>
+            <a:picLocks noChangeAspect="1"/>
+          </p:cNvPicPr>
+          <p:nvPr/>
+        </p:nvPicPr>
+        <p:blipFill>
+          <a:blip r:embed="rId2"/>
+          <a:stretch>
+            <a:fillRect/>
+          </a:stretch>
+        </p:blipFill>
+        <p:spPr>
+          <a:xfrm>
+            <a:off x="457200" y="1553218"/>
+            <a:ext cx="5577840" cy="3888722"/>
+          </a:xfrm>
+          <a:prstGeom prst="rect">
+            <a:avLst/>
+          </a:prstGeom>
+          <a:ln w="9525">
+            <a:solidFill>
+              <a:srgbClr val="34A87E"/>
+            </a:solidFill>
+          </a:ln>
+        </p:spPr>
+      </p:pic>
+      <p:pic>
+        <p:nvPicPr>
+          <p:cNvPr id="8" name="Picture 7" descr="05b-advisor.jpg"/>
+          <p:cNvPicPr>
+            <a:picLocks noChangeAspect="1"/>
+          </p:cNvPicPr>
+          <p:nvPr/>
+        </p:nvPicPr>
+        <p:blipFill>
+          <a:blip r:embed="rId3"/>
+          <a:stretch>
+            <a:fillRect/>
+          </a:stretch>
+        </p:blipFill>
+        <p:spPr>
+          <a:xfrm>
+            <a:off x="6172200" y="1521452"/>
+            <a:ext cx="5577840" cy="3952254"/>
+          </a:xfrm>
+          <a:prstGeom prst="rect">
+            <a:avLst/>
+          </a:prstGeom>
+          <a:ln w="9525">
+            <a:solidFill>
+              <a:srgbClr val="34A87E"/>
+            </a:solidFill>
+          </a:ln>
+        </p:spPr>
+      </p:pic>
+      <p:sp>
+        <p:nvSpPr>
+          <p:cNvPr id="9" name="Rounded Rectangle 8"/>
+          <p:cNvSpPr/>
+          <p:nvPr/>
+        </p:nvSpPr>
+        <p:spPr>
+          <a:xfrm>
+            <a:off x="457200" y="5806440"/>
+            <a:ext cx="11247120" cy="502920"/>
+          </a:xfrm>
+          <a:prstGeom prst="roundRect">
+            <a:avLst/>
+          </a:prstGeom>
+          <a:solidFill>
+            <a:srgbClr val="181F2A"/>
+          </a:solidFill>
+          <a:ln w="9525">
+            <a:solidFill>
+              <a:srgbClr val="34A87E"/>
+            </a:solidFill>
+          </a:ln>
+          <a:effectLst/>
+        </p:spPr>
+        <p:style>
+          <a:lnRef idx="1">
+            <a:schemeClr val="accent1"/>
+          </a:lnRef>
+          <a:fillRef idx="3">
+            <a:schemeClr val="accent1"/>
+          </a:fillRef>
+          <a:effectRef idx="2">
+            <a:schemeClr val="accent1"/>
+          </a:effectRef>
+          <a:fontRef idx="minor">
+            <a:schemeClr val="lt1"/>
+          </a:fontRef>
+        </p:style>
+        <p:txBody>
+          <a:bodyPr rtlCol="0" anchor="ctr"/>
+          <a:lstStyle/>
+          <a:p>
+            <a:pPr algn="ctr"/>
+          </a:p>
+        </p:txBody>
+      </p:sp>
+      <p:sp>
+        <p:nvSpPr>
+          <p:cNvPr id="10" name="TextBox 9"/>
+          <p:cNvSpPr txBox="1"/>
+          <p:nvPr/>
+        </p:nvSpPr>
+        <p:spPr>
+          <a:xfrm>
+            <a:off x="685800" y="5897880"/>
+            <a:ext cx="10789920" cy="365760"/>
+          </a:xfrm>
+          <a:prstGeom prst="rect">
+            <a:avLst/>
+          </a:prstGeom>
+          <a:noFill/>
+        </p:spPr>
+        <p:txBody>
+          <a:bodyPr wrap="square" lIns="45720" rIns="45720" tIns="18288" bIns="18288">
+            <a:spAutoFit/>
+          </a:bodyPr>
+          <a:lstStyle/>
+          <a:p>
+            <a:pPr algn="l"/>
+            <a:r>
+              <a:rPr sz="1300" b="0">
+                <a:solidFill>
+                  <a:srgbClr val="E8ECF1"/>
+                </a:solidFill>
+                <a:latin typeface="Segoe UI"/>
+              </a:rPr>
+              <a:t>Left: four agents running in parallel.   Right: one of them consults the advisor on a header-length bound.</a:t>
+            </a:r>
+          </a:p>
+        </p:txBody>
+      </p:sp>
+      <p:sp>
+        <p:nvSpPr>
+          <p:cNvPr id="11" name="TextBox 10"/>
+          <p:cNvSpPr txBox="1"/>
+          <p:nvPr/>
+        </p:nvSpPr>
+        <p:spPr>
+          <a:xfrm>
+            <a:off x="457200" y="6400800"/>
+            <a:ext cx="5486400" cy="274320"/>
+          </a:xfrm>
+          <a:prstGeom prst="rect">
+            <a:avLst/>
+          </a:prstGeom>
+          <a:noFill/>
+        </p:spPr>
+        <p:txBody>
+          <a:bodyPr wrap="square" lIns="45720" rIns="45720" tIns="18288" bIns="18288">
+            <a:spAutoFit/>
+          </a:bodyPr>
+          <a:lstStyle/>
+          <a:p>
+            <a:pPr algn="l"/>
+            <a:r>
+              <a:rPr sz="1000" b="0">
+                <a:solidFill>
+                  <a:srgbClr val="9AA3AF"/>
+                </a:solidFill>
+                <a:latin typeface="Segoe UI"/>
+              </a:rPr>
+              <a:t>EFF-IT  —  A Claude Code harness</a:t>
+            </a:r>
+          </a:p>
+        </p:txBody>
+      </p:sp>
+      <p:sp>
+        <p:nvSpPr>
+          <p:cNvPr id="12" name="TextBox 11"/>
+          <p:cNvSpPr txBox="1"/>
+          <p:nvPr/>
+        </p:nvSpPr>
+        <p:spPr>
+          <a:xfrm>
+            <a:off x="10515600" y="6400800"/>
+            <a:ext cx="1645920" cy="274320"/>
+          </a:xfrm>
+          <a:prstGeom prst="rect">
+            <a:avLst/>
+          </a:prstGeom>
+          <a:noFill/>
+        </p:spPr>
+        <p:txBody>
+          <a:bodyPr wrap="square" lIns="45720" rIns="45720" tIns="18288" bIns="18288">
+            <a:spAutoFit/>
+          </a:bodyPr>
+          <a:lstStyle/>
+          <a:p>
+            <a:pPr algn="r"/>
+            <a:r>
+              <a:rPr sz="1000" b="0">
+                <a:solidFill>
+                  <a:srgbClr val="9AA3AF"/>
+                </a:solidFill>
+                <a:latin typeface="Segoe UI"/>
+              </a:rPr>
+              <a:t>20 / 23</a:t>
+            </a:r>
+          </a:p>
+        </p:txBody>
+      </p:sp>
+    </p:spTree>
+  </p:cSld>
+  <p:clrMapOvr>
+    <a:masterClrMapping/>
+  </p:clrMapOvr>
+</p:sld>
+</file>
+
+<file path=ppt/slides/slide21.xml><?xml version="1.0" encoding="utf-8"?>
+<p:sld xmlns:a="http://schemas.openxmlformats.org/drawingml/2006/main" xmlns:p="http://schemas.openxmlformats.org/presentationml/2006/main" xmlns:r="http://schemas.openxmlformats.org/officeDocument/2006/relationships">
+  <p:cSld>
+    <p:spTree>
+      <p:nvGrpSpPr>
+        <p:cNvPr id="1" name=""/>
+        <p:cNvGrpSpPr/>
+        <p:nvPr/>
+      </p:nvGrpSpPr>
+      <p:grpSpPr/>
+      <p:sp>
+        <p:nvSpPr>
+          <p:cNvPr id="2" name="Rectangle 1"/>
+          <p:cNvSpPr/>
+          <p:nvPr/>
+        </p:nvSpPr>
+        <p:spPr>
+          <a:xfrm>
+            <a:off x="0" y="0"/>
+            <a:ext cx="12191695" cy="6858000"/>
+          </a:xfrm>
+          <a:prstGeom prst="rect">
+            <a:avLst/>
+          </a:prstGeom>
+          <a:solidFill>
+            <a:srgbClr val="0F141A"/>
+          </a:solidFill>
+          <a:ln>
+            <a:noFill/>
+          </a:ln>
+          <a:effectLst/>
+        </p:spPr>
+        <p:style>
+          <a:lnRef idx="1">
+            <a:schemeClr val="accent1"/>
+          </a:lnRef>
+          <a:fillRef idx="3">
+            <a:schemeClr val="accent1"/>
+          </a:fillRef>
+          <a:effectRef idx="2">
+            <a:schemeClr val="accent1"/>
+          </a:effectRef>
+          <a:fontRef idx="minor">
+            <a:schemeClr val="lt1"/>
+          </a:fontRef>
+        </p:style>
+        <p:txBody>
+          <a:bodyPr rtlCol="0" anchor="ctr"/>
+          <a:lstStyle/>
+          <a:p>
+            <a:pPr algn="ctr"/>
+          </a:p>
+        </p:txBody>
+      </p:sp>
+      <p:sp>
+        <p:nvSpPr>
+          <p:cNvPr id="3" name="Rectangle 2"/>
+          <p:cNvSpPr/>
+          <p:nvPr/>
+        </p:nvSpPr>
+        <p:spPr>
+          <a:xfrm>
+            <a:off x="457200" y="411480"/>
+            <a:ext cx="73152" cy="502920"/>
+          </a:xfrm>
+          <a:prstGeom prst="rect">
+            <a:avLst/>
+          </a:prstGeom>
+          <a:solidFill>
+            <a:srgbClr val="6EE7B7"/>
+          </a:solidFill>
+          <a:ln>
+            <a:noFill/>
+          </a:ln>
+          <a:effectLst/>
+        </p:spPr>
+        <p:style>
+          <a:lnRef idx="1">
+            <a:schemeClr val="accent1"/>
+          </a:lnRef>
+          <a:fillRef idx="3">
+            <a:schemeClr val="accent1"/>
+          </a:fillRef>
+          <a:effectRef idx="2">
+            <a:schemeClr val="accent1"/>
+          </a:effectRef>
+          <a:fontRef idx="minor">
+            <a:schemeClr val="lt1"/>
+          </a:fontRef>
+        </p:style>
+        <p:txBody>
+          <a:bodyPr rtlCol="0" anchor="ctr"/>
+          <a:lstStyle/>
+          <a:p>
+            <a:pPr algn="ctr"/>
+          </a:p>
+        </p:txBody>
+      </p:sp>
+      <p:sp>
+        <p:nvSpPr>
+          <p:cNvPr id="4" name="TextBox 3"/>
+          <p:cNvSpPr txBox="1"/>
+          <p:nvPr/>
+        </p:nvSpPr>
+        <p:spPr>
+          <a:xfrm>
+            <a:off x="685800" y="292608"/>
+            <a:ext cx="1828800" cy="365760"/>
+          </a:xfrm>
+          <a:prstGeom prst="rect">
+            <a:avLst/>
+          </a:prstGeom>
+          <a:noFill/>
+        </p:spPr>
+        <p:txBody>
+          <a:bodyPr wrap="square" lIns="45720" rIns="45720" tIns="18288" bIns="18288">
+            <a:spAutoFit/>
+          </a:bodyPr>
+          <a:lstStyle/>
+          <a:p>
+            <a:pPr algn="l"/>
+            <a:r>
+              <a:rPr sz="1100" b="1">
+                <a:solidFill>
+                  <a:srgbClr val="6EE7B7"/>
+                </a:solidFill>
+                <a:latin typeface="Segoe UI"/>
+              </a:rPr>
+              <a:t>APPENDIX · 6 / 8</a:t>
+            </a:r>
+          </a:p>
+        </p:txBody>
+      </p:sp>
+      <p:sp>
+        <p:nvSpPr>
+          <p:cNvPr id="5" name="TextBox 4"/>
+          <p:cNvSpPr txBox="1"/>
+          <p:nvPr/>
+        </p:nvSpPr>
+        <p:spPr>
+          <a:xfrm>
+            <a:off x="685800" y="594360"/>
+            <a:ext cx="10972800" cy="457200"/>
+          </a:xfrm>
+          <a:prstGeom prst="rect">
+            <a:avLst/>
+          </a:prstGeom>
+          <a:noFill/>
+        </p:spPr>
+        <p:txBody>
+          <a:bodyPr wrap="square" lIns="45720" rIns="45720" tIns="18288" bIns="18288">
+            <a:spAutoFit/>
+          </a:bodyPr>
+          <a:lstStyle/>
+          <a:p>
+            <a:pPr algn="l"/>
+            <a:r>
+              <a:rPr sz="2400" b="1">
+                <a:solidFill>
+                  <a:srgbClr val="E8ECF1"/>
+                </a:solidFill>
+                <a:latin typeface="Segoe UI"/>
+              </a:rPr>
+              <a:t>Karen + human-in-the-loop triage</a:t>
+            </a:r>
+          </a:p>
+        </p:txBody>
+      </p:sp>
+      <p:sp>
+        <p:nvSpPr>
+          <p:cNvPr id="6" name="TextBox 5"/>
+          <p:cNvSpPr txBox="1"/>
+          <p:nvPr/>
+        </p:nvSpPr>
+        <p:spPr>
+          <a:xfrm>
+            <a:off x="685800" y="960120"/>
+            <a:ext cx="10972800" cy="320040"/>
+          </a:xfrm>
+          <a:prstGeom prst="rect">
+            <a:avLst/>
+          </a:prstGeom>
+          <a:noFill/>
+        </p:spPr>
+        <p:txBody>
+          <a:bodyPr wrap="square" lIns="45720" rIns="45720" tIns="18288" bIns="18288">
+            <a:spAutoFit/>
+          </a:bodyPr>
+          <a:lstStyle/>
+          <a:p>
+            <a:pPr algn="l"/>
+            <a:r>
+              <a:rPr sz="1200" b="0">
+                <a:solidFill>
+                  <a:srgbClr val="9AA3AF"/>
+                </a:solidFill>
+                <a:latin typeface="Segoe UI"/>
+              </a:rPr>
+              <a:t>When the audit surfaces work outside scope, the human stays in control</a:t>
+            </a:r>
+          </a:p>
+        </p:txBody>
+      </p:sp>
+      <p:pic>
+        <p:nvPicPr>
+          <p:cNvPr id="7" name="Picture 6" descr="06-karen-triage.jpg"/>
+          <p:cNvPicPr>
+            <a:picLocks noChangeAspect="1"/>
+          </p:cNvPicPr>
+          <p:nvPr/>
+        </p:nvPicPr>
+        <p:blipFill>
+          <a:blip r:embed="rId2"/>
+          <a:stretch>
+            <a:fillRect/>
+          </a:stretch>
+        </p:blipFill>
+        <p:spPr>
+          <a:xfrm>
+            <a:off x="1884843" y="1325880"/>
+            <a:ext cx="8391832" cy="4343400"/>
+          </a:xfrm>
+          <a:prstGeom prst="rect">
+            <a:avLst/>
+          </a:prstGeom>
+          <a:ln w="9525">
+            <a:solidFill>
+              <a:srgbClr val="34A87E"/>
+            </a:solidFill>
+          </a:ln>
+        </p:spPr>
+      </p:pic>
+      <p:sp>
+        <p:nvSpPr>
+          <p:cNvPr id="8" name="Rounded Rectangle 7"/>
+          <p:cNvSpPr/>
+          <p:nvPr/>
+        </p:nvSpPr>
+        <p:spPr>
+          <a:xfrm>
+            <a:off x="457200" y="5806440"/>
+            <a:ext cx="11247120" cy="502920"/>
+          </a:xfrm>
+          <a:prstGeom prst="roundRect">
+            <a:avLst/>
+          </a:prstGeom>
+          <a:solidFill>
+            <a:srgbClr val="181F2A"/>
+          </a:solidFill>
+          <a:ln w="9525">
+            <a:solidFill>
+              <a:srgbClr val="34A87E"/>
+            </a:solidFill>
+          </a:ln>
+          <a:effectLst/>
+        </p:spPr>
+        <p:style>
+          <a:lnRef idx="1">
+            <a:schemeClr val="accent1"/>
+          </a:lnRef>
+          <a:fillRef idx="3">
+            <a:schemeClr val="accent1"/>
+          </a:fillRef>
+          <a:effectRef idx="2">
+            <a:schemeClr val="accent1"/>
+          </a:effectRef>
+          <a:fontRef idx="minor">
+            <a:schemeClr val="lt1"/>
+          </a:fontRef>
+        </p:style>
+        <p:txBody>
+          <a:bodyPr rtlCol="0" anchor="ctr"/>
+          <a:lstStyle/>
+          <a:p>
+            <a:pPr algn="ctr"/>
+          </a:p>
+        </p:txBody>
+      </p:sp>
+      <p:sp>
+        <p:nvSpPr>
+          <p:cNvPr id="9" name="TextBox 8"/>
+          <p:cNvSpPr txBox="1"/>
+          <p:nvPr/>
+        </p:nvSpPr>
+        <p:spPr>
+          <a:xfrm>
+            <a:off x="685800" y="5897880"/>
+            <a:ext cx="10789920" cy="365760"/>
+          </a:xfrm>
+          <a:prstGeom prst="rect">
+            <a:avLst/>
+          </a:prstGeom>
+          <a:noFill/>
+        </p:spPr>
+        <p:txBody>
+          <a:bodyPr wrap="square" lIns="45720" rIns="45720" tIns="18288" bIns="18288">
+            <a:spAutoFit/>
+          </a:bodyPr>
+          <a:lstStyle/>
+          <a:p>
+            <a:pPr algn="l"/>
+            <a:r>
+              <a:rPr sz="1300" b="0">
+                <a:solidFill>
+                  <a:srgbClr val="E8ECF1"/>
+                </a:solidFill>
+                <a:latin typeface="Segoe UI"/>
+              </a:rPr>
+              <a:t>160 / 182 tests pass. 22 failures = pre-existing test bugs. Karen names the failure mode and proceeds. Human picked Option C.</a:t>
+            </a:r>
+          </a:p>
+        </p:txBody>
+      </p:sp>
+      <p:sp>
+        <p:nvSpPr>
+          <p:cNvPr id="10" name="TextBox 9"/>
+          <p:cNvSpPr txBox="1"/>
+          <p:nvPr/>
+        </p:nvSpPr>
+        <p:spPr>
+          <a:xfrm>
+            <a:off x="457200" y="6400800"/>
+            <a:ext cx="5486400" cy="274320"/>
+          </a:xfrm>
+          <a:prstGeom prst="rect">
+            <a:avLst/>
+          </a:prstGeom>
+          <a:noFill/>
+        </p:spPr>
+        <p:txBody>
+          <a:bodyPr wrap="square" lIns="45720" rIns="45720" tIns="18288" bIns="18288">
+            <a:spAutoFit/>
+          </a:bodyPr>
+          <a:lstStyle/>
+          <a:p>
+            <a:pPr algn="l"/>
+            <a:r>
+              <a:rPr sz="1000" b="0">
+                <a:solidFill>
+                  <a:srgbClr val="9AA3AF"/>
+                </a:solidFill>
+                <a:latin typeface="Segoe UI"/>
+              </a:rPr>
+              <a:t>EFF-IT  —  A Claude Code harness</a:t>
+            </a:r>
+          </a:p>
+        </p:txBody>
+      </p:sp>
+      <p:sp>
+        <p:nvSpPr>
+          <p:cNvPr id="11" name="TextBox 10"/>
+          <p:cNvSpPr txBox="1"/>
+          <p:nvPr/>
+        </p:nvSpPr>
+        <p:spPr>
+          <a:xfrm>
+            <a:off x="10515600" y="6400800"/>
+            <a:ext cx="1645920" cy="274320"/>
+          </a:xfrm>
+          <a:prstGeom prst="rect">
+            <a:avLst/>
+          </a:prstGeom>
+          <a:noFill/>
+        </p:spPr>
+        <p:txBody>
+          <a:bodyPr wrap="square" lIns="45720" rIns="45720" tIns="18288" bIns="18288">
+            <a:spAutoFit/>
+          </a:bodyPr>
+          <a:lstStyle/>
+          <a:p>
+            <a:pPr algn="r"/>
+            <a:r>
+              <a:rPr sz="1000" b="0">
+                <a:solidFill>
+                  <a:srgbClr val="9AA3AF"/>
+                </a:solidFill>
+                <a:latin typeface="Segoe UI"/>
+              </a:rPr>
+              <a:t>21 / 23</a:t>
+            </a:r>
+          </a:p>
+        </p:txBody>
+      </p:sp>
+    </p:spTree>
+  </p:cSld>
+  <p:clrMapOvr>
+    <a:masterClrMapping/>
+  </p:clrMapOvr>
+</p:sld>
+</file>
+
+<file path=ppt/slides/slide22.xml><?xml version="1.0" encoding="utf-8"?>
+<p:sld xmlns:a="http://schemas.openxmlformats.org/drawingml/2006/main" xmlns:p="http://schemas.openxmlformats.org/presentationml/2006/main" xmlns:r="http://schemas.openxmlformats.org/officeDocument/2006/relationships">
+  <p:cSld>
+    <p:spTree>
+      <p:nvGrpSpPr>
+        <p:cNvPr id="1" name=""/>
+        <p:cNvGrpSpPr/>
+        <p:nvPr/>
+      </p:nvGrpSpPr>
+      <p:grpSpPr/>
+      <p:sp>
+        <p:nvSpPr>
+          <p:cNvPr id="2" name="Rectangle 1"/>
+          <p:cNvSpPr/>
+          <p:nvPr/>
+        </p:nvSpPr>
+        <p:spPr>
+          <a:xfrm>
+            <a:off x="0" y="0"/>
+            <a:ext cx="12191695" cy="6858000"/>
+          </a:xfrm>
+          <a:prstGeom prst="rect">
+            <a:avLst/>
+          </a:prstGeom>
+          <a:solidFill>
+            <a:srgbClr val="0F141A"/>
+          </a:solidFill>
+          <a:ln>
+            <a:noFill/>
+          </a:ln>
+          <a:effectLst/>
+        </p:spPr>
+        <p:style>
+          <a:lnRef idx="1">
+            <a:schemeClr val="accent1"/>
+          </a:lnRef>
+          <a:fillRef idx="3">
+            <a:schemeClr val="accent1"/>
+          </a:fillRef>
+          <a:effectRef idx="2">
+            <a:schemeClr val="accent1"/>
+          </a:effectRef>
+          <a:fontRef idx="minor">
+            <a:schemeClr val="lt1"/>
+          </a:fontRef>
+        </p:style>
+        <p:txBody>
+          <a:bodyPr rtlCol="0" anchor="ctr"/>
+          <a:lstStyle/>
+          <a:p>
+            <a:pPr algn="ctr"/>
+          </a:p>
+        </p:txBody>
+      </p:sp>
+      <p:sp>
+        <p:nvSpPr>
+          <p:cNvPr id="3" name="Rectangle 2"/>
+          <p:cNvSpPr/>
+          <p:nvPr/>
+        </p:nvSpPr>
+        <p:spPr>
+          <a:xfrm>
+            <a:off x="457200" y="411480"/>
+            <a:ext cx="73152" cy="502920"/>
+          </a:xfrm>
+          <a:prstGeom prst="rect">
+            <a:avLst/>
+          </a:prstGeom>
+          <a:solidFill>
+            <a:srgbClr val="6EE7B7"/>
+          </a:solidFill>
+          <a:ln>
+            <a:noFill/>
+          </a:ln>
+          <a:effectLst/>
+        </p:spPr>
+        <p:style>
+          <a:lnRef idx="1">
+            <a:schemeClr val="accent1"/>
+          </a:lnRef>
+          <a:fillRef idx="3">
+            <a:schemeClr val="accent1"/>
+          </a:fillRef>
+          <a:effectRef idx="2">
+            <a:schemeClr val="accent1"/>
+          </a:effectRef>
+          <a:fontRef idx="minor">
+            <a:schemeClr val="lt1"/>
+          </a:fontRef>
+        </p:style>
+        <p:txBody>
+          <a:bodyPr rtlCol="0" anchor="ctr"/>
+          <a:lstStyle/>
+          <a:p>
+            <a:pPr algn="ctr"/>
+          </a:p>
+        </p:txBody>
+      </p:sp>
+      <p:sp>
+        <p:nvSpPr>
+          <p:cNvPr id="4" name="TextBox 3"/>
+          <p:cNvSpPr txBox="1"/>
+          <p:nvPr/>
+        </p:nvSpPr>
+        <p:spPr>
+          <a:xfrm>
+            <a:off x="685800" y="292608"/>
+            <a:ext cx="1828800" cy="365760"/>
+          </a:xfrm>
+          <a:prstGeom prst="rect">
+            <a:avLst/>
+          </a:prstGeom>
+          <a:noFill/>
+        </p:spPr>
+        <p:txBody>
+          <a:bodyPr wrap="square" lIns="45720" rIns="45720" tIns="18288" bIns="18288">
+            <a:spAutoFit/>
+          </a:bodyPr>
+          <a:lstStyle/>
+          <a:p>
+            <a:pPr algn="l"/>
+            <a:r>
+              <a:rPr sz="1100" b="1">
+                <a:solidFill>
+                  <a:srgbClr val="6EE7B7"/>
+                </a:solidFill>
+                <a:latin typeface="Segoe UI"/>
+              </a:rPr>
+              <a:t>APPENDIX · 7 / 8</a:t>
+            </a:r>
+          </a:p>
+        </p:txBody>
+      </p:sp>
+      <p:sp>
+        <p:nvSpPr>
+          <p:cNvPr id="5" name="TextBox 4"/>
+          <p:cNvSpPr txBox="1"/>
+          <p:nvPr/>
+        </p:nvSpPr>
+        <p:spPr>
+          <a:xfrm>
+            <a:off x="685800" y="594360"/>
+            <a:ext cx="10972800" cy="457200"/>
+          </a:xfrm>
+          <a:prstGeom prst="rect">
+            <a:avLst/>
+          </a:prstGeom>
+          <a:noFill/>
+        </p:spPr>
+        <p:txBody>
+          <a:bodyPr wrap="square" lIns="45720" rIns="45720" tIns="18288" bIns="18288">
+            <a:spAutoFit/>
+          </a:bodyPr>
+          <a:lstStyle/>
+          <a:p>
+            <a:pPr algn="l"/>
+            <a:r>
+              <a:rPr sz="2400" b="1">
+                <a:solidFill>
+                  <a:srgbClr val="E8ECF1"/>
+                </a:solidFill>
+                <a:latin typeface="Segoe UI"/>
+              </a:rPr>
+              <a:t>The final scoreboard</a:t>
+            </a:r>
+          </a:p>
+        </p:txBody>
+      </p:sp>
+      <p:sp>
+        <p:nvSpPr>
+          <p:cNvPr id="6" name="TextBox 5"/>
+          <p:cNvSpPr txBox="1"/>
+          <p:nvPr/>
+        </p:nvSpPr>
+        <p:spPr>
+          <a:xfrm>
+            <a:off x="685800" y="960120"/>
+            <a:ext cx="10972800" cy="320040"/>
+          </a:xfrm>
+          <a:prstGeom prst="rect">
+            <a:avLst/>
+          </a:prstGeom>
+          <a:noFill/>
+        </p:spPr>
+        <p:txBody>
+          <a:bodyPr wrap="square" lIns="45720" rIns="45720" tIns="18288" bIns="18288">
+            <a:spAutoFit/>
+          </a:bodyPr>
+          <a:lstStyle/>
+          <a:p>
+            <a:pPr algn="l"/>
+            <a:r>
+              <a:rPr sz="1200" b="0">
+                <a:solidFill>
+                  <a:srgbClr val="9AA3AF"/>
+                </a:solidFill>
+                <a:latin typeface="Segoe UI"/>
+              </a:rPr>
+              <a:t>Every stage's result, one screen, baked in 30 m 13 s</a:t>
+            </a:r>
+          </a:p>
+        </p:txBody>
+      </p:sp>
+      <p:pic>
+        <p:nvPicPr>
+          <p:cNvPr id="7" name="Picture 6" descr="07-scoreboard.jpg"/>
+          <p:cNvPicPr>
+            <a:picLocks noChangeAspect="1"/>
+          </p:cNvPicPr>
+          <p:nvPr/>
+        </p:nvPicPr>
+        <p:blipFill>
+          <a:blip r:embed="rId2"/>
+          <a:stretch>
+            <a:fillRect/>
+          </a:stretch>
+        </p:blipFill>
+        <p:spPr>
+          <a:xfrm>
+            <a:off x="1940052" y="1325880"/>
+            <a:ext cx="8281416" cy="4343400"/>
+          </a:xfrm>
+          <a:prstGeom prst="rect">
+            <a:avLst/>
+          </a:prstGeom>
+          <a:ln w="9525">
+            <a:solidFill>
+              <a:srgbClr val="34A87E"/>
+            </a:solidFill>
+          </a:ln>
+        </p:spPr>
+      </p:pic>
+      <p:sp>
+        <p:nvSpPr>
+          <p:cNvPr id="8" name="Rounded Rectangle 7"/>
+          <p:cNvSpPr/>
+          <p:nvPr/>
+        </p:nvSpPr>
+        <p:spPr>
+          <a:xfrm>
+            <a:off x="457200" y="5806440"/>
+            <a:ext cx="11247120" cy="502920"/>
+          </a:xfrm>
+          <a:prstGeom prst="roundRect">
+            <a:avLst/>
+          </a:prstGeom>
+          <a:solidFill>
+            <a:srgbClr val="181F2A"/>
+          </a:solidFill>
+          <a:ln w="9525">
+            <a:solidFill>
+              <a:srgbClr val="34A87E"/>
+            </a:solidFill>
+          </a:ln>
+          <a:effectLst/>
+        </p:spPr>
+        <p:style>
+          <a:lnRef idx="1">
+            <a:schemeClr val="accent1"/>
+          </a:lnRef>
+          <a:fillRef idx="3">
+            <a:schemeClr val="accent1"/>
+          </a:fillRef>
+          <a:effectRef idx="2">
+            <a:schemeClr val="accent1"/>
+          </a:effectRef>
+          <a:fontRef idx="minor">
+            <a:schemeClr val="lt1"/>
+          </a:fontRef>
+        </p:style>
+        <p:txBody>
+          <a:bodyPr rtlCol="0" anchor="ctr"/>
+          <a:lstStyle/>
+          <a:p>
+            <a:pPr algn="ctr"/>
+          </a:p>
+        </p:txBody>
+      </p:sp>
+      <p:sp>
+        <p:nvSpPr>
+          <p:cNvPr id="9" name="TextBox 8"/>
+          <p:cNvSpPr txBox="1"/>
+          <p:nvPr/>
+        </p:nvSpPr>
+        <p:spPr>
+          <a:xfrm>
+            <a:off x="685800" y="5897880"/>
+            <a:ext cx="10789920" cy="365760"/>
+          </a:xfrm>
+          <a:prstGeom prst="rect">
+            <a:avLst/>
+          </a:prstGeom>
+          <a:noFill/>
+        </p:spPr>
+        <p:txBody>
+          <a:bodyPr wrap="square" lIns="45720" rIns="45720" tIns="18288" bIns="18288">
+            <a:spAutoFit/>
+          </a:bodyPr>
+          <a:lstStyle/>
+          <a:p>
+            <a:pPr algn="l"/>
+            <a:r>
+              <a:rPr sz="1300" b="0">
+                <a:solidFill>
+                  <a:srgbClr val="6EE7B7"/>
+                </a:solidFill>
+                <a:latin typeface="Segoe UI"/>
+              </a:rPr>
+              <a:t>TDD red phase · parallel + sequential coders · 22 pre-existing fails accepted · 2 medium security findings · 1 fixed, 1 documented · PR open.</a:t>
+            </a:r>
+          </a:p>
+        </p:txBody>
+      </p:sp>
+      <p:sp>
+        <p:nvSpPr>
+          <p:cNvPr id="10" name="TextBox 9"/>
+          <p:cNvSpPr txBox="1"/>
+          <p:nvPr/>
+        </p:nvSpPr>
+        <p:spPr>
+          <a:xfrm>
+            <a:off x="457200" y="6400800"/>
+            <a:ext cx="5486400" cy="274320"/>
+          </a:xfrm>
+          <a:prstGeom prst="rect">
+            <a:avLst/>
+          </a:prstGeom>
+          <a:noFill/>
+        </p:spPr>
+        <p:txBody>
+          <a:bodyPr wrap="square" lIns="45720" rIns="45720" tIns="18288" bIns="18288">
+            <a:spAutoFit/>
+          </a:bodyPr>
+          <a:lstStyle/>
+          <a:p>
+            <a:pPr algn="l"/>
+            <a:r>
+              <a:rPr sz="1000" b="0">
+                <a:solidFill>
+                  <a:srgbClr val="9AA3AF"/>
+                </a:solidFill>
+                <a:latin typeface="Segoe UI"/>
+              </a:rPr>
+              <a:t>EFF-IT  —  A Claude Code harness</a:t>
+            </a:r>
+          </a:p>
+        </p:txBody>
+      </p:sp>
+      <p:sp>
+        <p:nvSpPr>
+          <p:cNvPr id="11" name="TextBox 10"/>
+          <p:cNvSpPr txBox="1"/>
+          <p:nvPr/>
+        </p:nvSpPr>
+        <p:spPr>
+          <a:xfrm>
+            <a:off x="10515600" y="6400800"/>
+            <a:ext cx="1645920" cy="274320"/>
+          </a:xfrm>
+          <a:prstGeom prst="rect">
+            <a:avLst/>
+          </a:prstGeom>
+          <a:noFill/>
+        </p:spPr>
+        <p:txBody>
+          <a:bodyPr wrap="square" lIns="45720" rIns="45720" tIns="18288" bIns="18288">
+            <a:spAutoFit/>
+          </a:bodyPr>
+          <a:lstStyle/>
+          <a:p>
+            <a:pPr algn="r"/>
+            <a:r>
+              <a:rPr sz="1000" b="0">
+                <a:solidFill>
+                  <a:srgbClr val="9AA3AF"/>
+                </a:solidFill>
+                <a:latin typeface="Segoe UI"/>
+              </a:rPr>
+              <a:t>22 / 23</a:t>
+            </a:r>
+          </a:p>
+        </p:txBody>
+      </p:sp>
+    </p:spTree>
+  </p:cSld>
+  <p:clrMapOvr>
+    <a:masterClrMapping/>
+  </p:clrMapOvr>
+</p:sld>
+</file>
+
+<file path=ppt/slides/slide23.xml><?xml version="1.0" encoding="utf-8"?>
+<p:sld xmlns:a="http://schemas.openxmlformats.org/drawingml/2006/main" xmlns:p="http://schemas.openxmlformats.org/presentationml/2006/main" xmlns:r="http://schemas.openxmlformats.org/officeDocument/2006/relationships">
+  <p:cSld>
+    <p:spTree>
+      <p:nvGrpSpPr>
+        <p:cNvPr id="1" name=""/>
+        <p:cNvGrpSpPr/>
+        <p:nvPr/>
+      </p:nvGrpSpPr>
+      <p:grpSpPr/>
+      <p:sp>
+        <p:nvSpPr>
+          <p:cNvPr id="2" name="Rectangle 1"/>
+          <p:cNvSpPr/>
+          <p:nvPr/>
+        </p:nvSpPr>
+        <p:spPr>
+          <a:xfrm>
+            <a:off x="0" y="0"/>
+            <a:ext cx="12191695" cy="6858000"/>
+          </a:xfrm>
+          <a:prstGeom prst="rect">
+            <a:avLst/>
+          </a:prstGeom>
+          <a:solidFill>
+            <a:srgbClr val="0F141A"/>
+          </a:solidFill>
+          <a:ln>
+            <a:noFill/>
+          </a:ln>
+          <a:effectLst/>
+        </p:spPr>
+        <p:style>
+          <a:lnRef idx="1">
+            <a:schemeClr val="accent1"/>
+          </a:lnRef>
+          <a:fillRef idx="3">
+            <a:schemeClr val="accent1"/>
+          </a:fillRef>
+          <a:effectRef idx="2">
+            <a:schemeClr val="accent1"/>
+          </a:effectRef>
+          <a:fontRef idx="minor">
+            <a:schemeClr val="lt1"/>
+          </a:fontRef>
+        </p:style>
+        <p:txBody>
+          <a:bodyPr rtlCol="0" anchor="ctr"/>
+          <a:lstStyle/>
+          <a:p>
+            <a:pPr algn="ctr"/>
+          </a:p>
+        </p:txBody>
+      </p:sp>
+      <p:sp>
+        <p:nvSpPr>
+          <p:cNvPr id="3" name="Rectangle 2"/>
+          <p:cNvSpPr/>
+          <p:nvPr/>
+        </p:nvSpPr>
+        <p:spPr>
+          <a:xfrm>
+            <a:off x="457200" y="411480"/>
+            <a:ext cx="73152" cy="502920"/>
+          </a:xfrm>
+          <a:prstGeom prst="rect">
+            <a:avLst/>
+          </a:prstGeom>
+          <a:solidFill>
+            <a:srgbClr val="6EE7B7"/>
+          </a:solidFill>
+          <a:ln>
+            <a:noFill/>
+          </a:ln>
+          <a:effectLst/>
+        </p:spPr>
+        <p:style>
+          <a:lnRef idx="1">
+            <a:schemeClr val="accent1"/>
+          </a:lnRef>
+          <a:fillRef idx="3">
+            <a:schemeClr val="accent1"/>
+          </a:fillRef>
+          <a:effectRef idx="2">
+            <a:schemeClr val="accent1"/>
+          </a:effectRef>
+          <a:fontRef idx="minor">
+            <a:schemeClr val="lt1"/>
+          </a:fontRef>
+        </p:style>
+        <p:txBody>
+          <a:bodyPr rtlCol="0" anchor="ctr"/>
+          <a:lstStyle/>
+          <a:p>
+            <a:pPr algn="ctr"/>
+          </a:p>
+        </p:txBody>
+      </p:sp>
+      <p:sp>
+        <p:nvSpPr>
+          <p:cNvPr id="4" name="TextBox 3"/>
+          <p:cNvSpPr txBox="1"/>
+          <p:nvPr/>
+        </p:nvSpPr>
+        <p:spPr>
+          <a:xfrm>
+            <a:off x="685800" y="292608"/>
+            <a:ext cx="1828800" cy="365760"/>
+          </a:xfrm>
+          <a:prstGeom prst="rect">
+            <a:avLst/>
+          </a:prstGeom>
+          <a:noFill/>
+        </p:spPr>
+        <p:txBody>
+          <a:bodyPr wrap="square" lIns="45720" rIns="45720" tIns="18288" bIns="18288">
+            <a:spAutoFit/>
+          </a:bodyPr>
+          <a:lstStyle/>
+          <a:p>
+            <a:pPr algn="l"/>
+            <a:r>
+              <a:rPr sz="1100" b="1">
+                <a:solidFill>
+                  <a:srgbClr val="6EE7B7"/>
+                </a:solidFill>
+                <a:latin typeface="Segoe UI"/>
+              </a:rPr>
+              <a:t>APPENDIX · 8 / 8</a:t>
+            </a:r>
+          </a:p>
+        </p:txBody>
+      </p:sp>
+      <p:sp>
+        <p:nvSpPr>
+          <p:cNvPr id="5" name="TextBox 4"/>
+          <p:cNvSpPr txBox="1"/>
+          <p:nvPr/>
+        </p:nvSpPr>
+        <p:spPr>
+          <a:xfrm>
+            <a:off x="685800" y="594360"/>
+            <a:ext cx="10972800" cy="457200"/>
+          </a:xfrm>
+          <a:prstGeom prst="rect">
+            <a:avLst/>
+          </a:prstGeom>
+          <a:noFill/>
+        </p:spPr>
+        <p:txBody>
+          <a:bodyPr wrap="square" lIns="45720" rIns="45720" tIns="18288" bIns="18288">
+            <a:spAutoFit/>
+          </a:bodyPr>
+          <a:lstStyle/>
+          <a:p>
+            <a:pPr algn="l"/>
+            <a:r>
+              <a:rPr sz="2400" b="1">
+                <a:solidFill>
+                  <a:srgbClr val="E8ECF1"/>
+                </a:solidFill>
+                <a:latin typeface="Segoe UI"/>
+              </a:rPr>
+              <a:t>Receipts under the hood</a:t>
+            </a:r>
+          </a:p>
+        </p:txBody>
+      </p:sp>
+      <p:sp>
+        <p:nvSpPr>
+          <p:cNvPr id="6" name="TextBox 5"/>
+          <p:cNvSpPr txBox="1"/>
+          <p:nvPr/>
+        </p:nvSpPr>
+        <p:spPr>
+          <a:xfrm>
+            <a:off x="685800" y="960120"/>
+            <a:ext cx="10972800" cy="320040"/>
+          </a:xfrm>
+          <a:prstGeom prst="rect">
+            <a:avLst/>
+          </a:prstGeom>
+          <a:noFill/>
+        </p:spPr>
+        <p:txBody>
+          <a:bodyPr wrap="square" lIns="45720" rIns="45720" tIns="18288" bIns="18288">
+            <a:spAutoFit/>
+          </a:bodyPr>
+          <a:lstStyle/>
+          <a:p>
+            <a:pPr algn="l"/>
+            <a:r>
+              <a:rPr sz="1200" b="0">
+                <a:solidFill>
+                  <a:srgbClr val="9AA3AF"/>
+                </a:solidFill>
+                <a:latin typeface="Segoe UI"/>
+              </a:rPr>
+              <a:t>The JSONL audit trail from slide 8, in the wild</a:t>
+            </a:r>
+          </a:p>
+        </p:txBody>
+      </p:sp>
+      <p:pic>
+        <p:nvPicPr>
+          <p:cNvPr id="7" name="Picture 6" descr="08a-jsonl-1.jpg"/>
+          <p:cNvPicPr>
+            <a:picLocks noChangeAspect="1"/>
+          </p:cNvPicPr>
+          <p:nvPr/>
+        </p:nvPicPr>
+        <p:blipFill>
+          <a:blip r:embed="rId2"/>
+          <a:stretch>
+            <a:fillRect/>
+          </a:stretch>
+        </p:blipFill>
+        <p:spPr>
+          <a:xfrm>
+            <a:off x="457200" y="2907817"/>
+            <a:ext cx="5577840" cy="1179524"/>
+          </a:xfrm>
+          <a:prstGeom prst="rect">
+            <a:avLst/>
+          </a:prstGeom>
+          <a:ln w="9525">
+            <a:solidFill>
+              <a:srgbClr val="34A87E"/>
+            </a:solidFill>
+          </a:ln>
+        </p:spPr>
+      </p:pic>
+      <p:pic>
+        <p:nvPicPr>
+          <p:cNvPr id="8" name="Picture 7" descr="08b-jsonl-2.jpg"/>
+          <p:cNvPicPr>
+            <a:picLocks noChangeAspect="1"/>
+          </p:cNvPicPr>
+          <p:nvPr/>
+        </p:nvPicPr>
+        <p:blipFill>
+          <a:blip r:embed="rId3"/>
+          <a:stretch>
+            <a:fillRect/>
+          </a:stretch>
+        </p:blipFill>
+        <p:spPr>
+          <a:xfrm>
+            <a:off x="6450679" y="1325880"/>
+            <a:ext cx="5020880" cy="4343400"/>
+          </a:xfrm>
+          <a:prstGeom prst="rect">
+            <a:avLst/>
+          </a:prstGeom>
+          <a:ln w="9525">
+            <a:solidFill>
+              <a:srgbClr val="34A87E"/>
+            </a:solidFill>
+          </a:ln>
+        </p:spPr>
+      </p:pic>
+      <p:sp>
+        <p:nvSpPr>
+          <p:cNvPr id="9" name="Rounded Rectangle 8"/>
+          <p:cNvSpPr/>
+          <p:nvPr/>
+        </p:nvSpPr>
+        <p:spPr>
+          <a:xfrm>
+            <a:off x="457200" y="5806440"/>
+            <a:ext cx="11247120" cy="502920"/>
+          </a:xfrm>
+          <a:prstGeom prst="roundRect">
+            <a:avLst/>
+          </a:prstGeom>
+          <a:solidFill>
+            <a:srgbClr val="181F2A"/>
+          </a:solidFill>
+          <a:ln w="9525">
+            <a:solidFill>
+              <a:srgbClr val="34A87E"/>
+            </a:solidFill>
+          </a:ln>
+          <a:effectLst/>
+        </p:spPr>
+        <p:style>
+          <a:lnRef idx="1">
+            <a:schemeClr val="accent1"/>
+          </a:lnRef>
+          <a:fillRef idx="3">
+            <a:schemeClr val="accent1"/>
+          </a:fillRef>
+          <a:effectRef idx="2">
+            <a:schemeClr val="accent1"/>
+          </a:effectRef>
+          <a:fontRef idx="minor">
+            <a:schemeClr val="lt1"/>
+          </a:fontRef>
+        </p:style>
+        <p:txBody>
+          <a:bodyPr rtlCol="0" anchor="ctr"/>
+          <a:lstStyle/>
+          <a:p>
+            <a:pPr algn="ctr"/>
+          </a:p>
+        </p:txBody>
+      </p:sp>
+      <p:sp>
+        <p:nvSpPr>
+          <p:cNvPr id="10" name="TextBox 9"/>
+          <p:cNvSpPr txBox="1"/>
+          <p:nvPr/>
+        </p:nvSpPr>
+        <p:spPr>
+          <a:xfrm>
+            <a:off x="685800" y="5897880"/>
+            <a:ext cx="10789920" cy="365760"/>
+          </a:xfrm>
+          <a:prstGeom prst="rect">
+            <a:avLst/>
+          </a:prstGeom>
+          <a:noFill/>
+        </p:spPr>
+        <p:txBody>
+          <a:bodyPr wrap="square" lIns="45720" rIns="45720" tIns="18288" bIns="18288">
+            <a:spAutoFit/>
+          </a:bodyPr>
+          <a:lstStyle/>
+          <a:p>
+            <a:pPr algn="l"/>
+            <a:r>
+              <a:rPr sz="1300" b="0">
+                <a:solidFill>
+                  <a:srgbClr val="E8ECF1"/>
+                </a:solidFill>
+                <a:latin typeface="Segoe UI"/>
+              </a:rPr>
+              <a:t>log_tool_call.sh in action: every Read, Bash, Edit, Agent spawn, web fetch — append-only JSONL.</a:t>
+            </a:r>
+          </a:p>
+        </p:txBody>
+      </p:sp>
+      <p:sp>
+        <p:nvSpPr>
+          <p:cNvPr id="11" name="TextBox 10"/>
+          <p:cNvSpPr txBox="1"/>
+          <p:nvPr/>
+        </p:nvSpPr>
+        <p:spPr>
+          <a:xfrm>
+            <a:off x="457200" y="6400800"/>
+            <a:ext cx="5486400" cy="274320"/>
+          </a:xfrm>
+          <a:prstGeom prst="rect">
+            <a:avLst/>
+          </a:prstGeom>
+          <a:noFill/>
+        </p:spPr>
+        <p:txBody>
+          <a:bodyPr wrap="square" lIns="45720" rIns="45720" tIns="18288" bIns="18288">
+            <a:spAutoFit/>
+          </a:bodyPr>
+          <a:lstStyle/>
+          <a:p>
+            <a:pPr algn="l"/>
+            <a:r>
+              <a:rPr sz="1000" b="0">
+                <a:solidFill>
+                  <a:srgbClr val="9AA3AF"/>
+                </a:solidFill>
+                <a:latin typeface="Segoe UI"/>
+              </a:rPr>
+              <a:t>EFF-IT  —  A Claude Code harness</a:t>
+            </a:r>
+          </a:p>
+        </p:txBody>
+      </p:sp>
+      <p:sp>
+        <p:nvSpPr>
+          <p:cNvPr id="12" name="TextBox 11"/>
+          <p:cNvSpPr txBox="1"/>
+          <p:nvPr/>
+        </p:nvSpPr>
+        <p:spPr>
+          <a:xfrm>
+            <a:off x="10515600" y="6400800"/>
+            <a:ext cx="1645920" cy="274320"/>
+          </a:xfrm>
+          <a:prstGeom prst="rect">
+            <a:avLst/>
+          </a:prstGeom>
+          <a:noFill/>
+        </p:spPr>
+        <p:txBody>
+          <a:bodyPr wrap="square" lIns="45720" rIns="45720" tIns="18288" bIns="18288">
+            <a:spAutoFit/>
+          </a:bodyPr>
+          <a:lstStyle/>
+          <a:p>
+            <a:pPr algn="r"/>
+            <a:r>
+              <a:rPr sz="1000" b="0">
+                <a:solidFill>
+                  <a:srgbClr val="9AA3AF"/>
+                </a:solidFill>
+                <a:latin typeface="Segoe UI"/>
+              </a:rPr>
+              <a:t>23 / 23</a:t>
             </a:r>
           </a:p>
         </p:txBody>
@@ -10408,7 +15268,7 @@
                 </a:solidFill>
                 <a:latin typeface="Segoe UI"/>
               </a:rPr>
-              <a:t>3 / 14</a:t>
+              <a:t>3 / 23</a:t>
             </a:r>
           </a:p>
         </p:txBody>
@@ -11304,7 +16164,7 @@
                 </a:solidFill>
                 <a:latin typeface="Segoe UI"/>
               </a:rPr>
-              <a:t>4 / 14</a:t>
+              <a:t>4 / 23</a:t>
             </a:r>
           </a:p>
         </p:txBody>
@@ -12388,7 +17248,7 @@
                 </a:solidFill>
                 <a:latin typeface="Segoe UI"/>
               </a:rPr>
-              <a:t>5 / 14</a:t>
+              <a:t>5 / 23</a:t>
             </a:r>
           </a:p>
         </p:txBody>
@@ -14054,7 +18914,7 @@
                 </a:solidFill>
                 <a:latin typeface="Segoe UI"/>
               </a:rPr>
-              <a:t>6 / 14</a:t>
+              <a:t>6 / 23</a:t>
             </a:r>
           </a:p>
         </p:txBody>
@@ -14996,7 +19856,7 @@
                 </a:solidFill>
                 <a:latin typeface="Segoe UI"/>
               </a:rPr>
-              <a:t>7 / 14</a:t>
+              <a:t>7 / 23</a:t>
             </a:r>
           </a:p>
         </p:txBody>
@@ -15744,7 +20604,7 @@
                 </a:solidFill>
                 <a:latin typeface="Segoe UI"/>
               </a:rPr>
-              <a:t>8 / 14</a:t>
+              <a:t>8 / 23</a:t>
             </a:r>
           </a:p>
         </p:txBody>
@@ -16572,7 +21432,7 @@
                 </a:solidFill>
                 <a:latin typeface="Segoe UI"/>
               </a:rPr>
-              <a:t>9 / 14</a:t>
+              <a:t>9 / 23</a:t>
             </a:r>
           </a:p>
         </p:txBody>

</xml_diff>